<commit_message>
Refine documentation and synchronization rules for Africa CDC and AUC projects. Update deliverable guidelines to ensure clarity and compliance with eligibility criteria. Enhance folder structure and source of truth files to prevent duplication and maintain alignment across formats. Introduce specific instructions for project-specific build scripts, emphasizing the importance of unique content generation for each application.
</commit_message>
<xml_diff>
--- a/applications/auda-srh/documents/auda-srh_ppt.pptx
+++ b/applications/auda-srh/documents/auda-srh_ppt.pptx
@@ -13,8 +13,6 @@
     <p:sldId id="261" r:id="rId12"/>
     <p:sldId id="262" r:id="rId13"/>
     <p:sldId id="263" r:id="rId14"/>
-    <p:sldId id="264" r:id="rId15"/>
-    <p:sldId id="265" r:id="rId16"/>
   </p:sldIdLst>
   <p:sldSz cx="12191695" cy="6858000" type="screen4x3"/>
   <p:notesSz cx="6858000" cy="9144000"/>
@@ -3107,7 +3105,6 @@
         </p:nvPicPr>
         <p:blipFill>
           <a:blip r:embed="rId2"/>
-          <a:srcRect l="33" r="33"/>
           <a:stretch>
             <a:fillRect/>
           </a:stretch>
@@ -3130,8 +3127,8 @@
         </p:nvSpPr>
         <p:spPr>
           <a:xfrm>
-            <a:off x="0" y="3474720"/>
-            <a:ext cx="12191695" cy="3383280"/>
+            <a:off x="0" y="3749040"/>
+            <a:ext cx="12191695" cy="3108960"/>
           </a:xfrm>
           <a:prstGeom prst="rect">
             <a:avLst/>
@@ -3142,7 +3139,6 @@
           <a:ln>
             <a:noFill/>
           </a:ln>
-          <a:effectLst/>
         </p:spPr>
         <p:style>
           <a:lnRef idx="1">
@@ -3174,7 +3170,7 @@
         </p:nvSpPr>
         <p:spPr>
           <a:xfrm>
-            <a:off x="594360" y="3749040"/>
+            <a:off x="548640" y="4023360"/>
             <a:ext cx="10972800" cy="320040"/>
           </a:xfrm>
           <a:prstGeom prst="rect">
@@ -3183,16 +3179,12 @@
           <a:noFill/>
         </p:spPr>
         <p:txBody>
-          <a:bodyPr wrap="square" anchor="t">
+          <a:bodyPr wrap="square">
             <a:spAutoFit/>
           </a:bodyPr>
           <a:lstStyle/>
           <a:p>
-            <a:pPr algn="l">
-              <a:spcAft>
-                <a:spcPts val="0"/>
-              </a:spcAft>
-            </a:pPr>
+            <a:pPr algn="l"/>
             <a:r>
               <a:rPr sz="1300" b="1" i="0">
                 <a:solidFill>
@@ -3213,8 +3205,8 @@
         </p:nvSpPr>
         <p:spPr>
           <a:xfrm>
-            <a:off x="594360" y="4206240"/>
-            <a:ext cx="10972800" cy="640080"/>
+            <a:off x="548640" y="4434840"/>
+            <a:ext cx="10972800" cy="548640"/>
           </a:xfrm>
           <a:prstGeom prst="rect">
             <a:avLst/>
@@ -3222,24 +3214,20 @@
           <a:noFill/>
         </p:spPr>
         <p:txBody>
-          <a:bodyPr wrap="square" anchor="t">
+          <a:bodyPr wrap="square">
             <a:spAutoFit/>
           </a:bodyPr>
           <a:lstStyle/>
           <a:p>
-            <a:pPr algn="l">
-              <a:spcAft>
-                <a:spcPts val="0"/>
-              </a:spcAft>
-            </a:pPr>
-            <a:r>
-              <a:rPr sz="2600" b="1" i="0">
+            <a:pPr algn="l"/>
+            <a:r>
+              <a:rPr sz="2400" b="1" i="0">
                 <a:solidFill>
                   <a:srgbClr val="FFFFFF"/>
                 </a:solidFill>
                 <a:latin typeface="Calibri"/>
               </a:rPr>
-              <a:t>Youth SRH Ambassadors for Community Health Intelligence</a:t>
+              <a:t>Ambassador Nomination — Advocacy &amp; Community Mobilisation</a:t>
             </a:r>
           </a:p>
         </p:txBody>
@@ -3252,8 +3240,8 @@
         </p:nvSpPr>
         <p:spPr>
           <a:xfrm>
-            <a:off x="594360" y="4983481"/>
-            <a:ext cx="10972800" cy="365760"/>
+            <a:off x="548640" y="5257800"/>
+            <a:ext cx="10972800" cy="320040"/>
           </a:xfrm>
           <a:prstGeom prst="rect">
             <a:avLst/>
@@ -3261,337 +3249,12 @@
           <a:noFill/>
         </p:spPr>
         <p:txBody>
-          <a:bodyPr wrap="square" anchor="t">
+          <a:bodyPr wrap="square">
             <a:spAutoFit/>
           </a:bodyPr>
           <a:lstStyle/>
           <a:p>
-            <a:pPr algn="l">
-              <a:spcAft>
-                <a:spcPts val="0"/>
-              </a:spcAft>
-            </a:pPr>
-            <a:r>
-              <a:rPr sz="1500" b="0" i="1">
-                <a:solidFill>
-                  <a:srgbClr val="F2C79B"/>
-                </a:solidFill>
-                <a:latin typeface="Calibri"/>
-              </a:rPr>
-              <a:t>Advocacy and mobilisation powered by FairBanks community reach</a:t>
-            </a:r>
-          </a:p>
-        </p:txBody>
-      </p:sp>
-      <p:sp>
-        <p:nvSpPr>
-          <p:cNvPr id="7" name="TextBox 6"/>
-          <p:cNvSpPr txBox="1"/>
-          <p:nvPr/>
-        </p:nvSpPr>
-        <p:spPr>
-          <a:xfrm>
-            <a:off x="594360" y="5532120"/>
-            <a:ext cx="10972800" cy="274320"/>
-          </a:xfrm>
-          <a:prstGeom prst="rect">
-            <a:avLst/>
-          </a:prstGeom>
-          <a:noFill/>
-        </p:spPr>
-        <p:txBody>
-          <a:bodyPr wrap="square" anchor="t">
-            <a:spAutoFit/>
-          </a:bodyPr>
-          <a:lstStyle/>
-          <a:p>
-            <a:pPr algn="l">
-              <a:spcAft>
-                <a:spcPts val="0"/>
-              </a:spcAft>
-            </a:pPr>
-            <a:r>
-              <a:rPr sz="1300" b="1" i="0">
-                <a:solidFill>
-                  <a:srgbClr val="FFFFFF"/>
-                </a:solidFill>
-                <a:latin typeface="Calibri"/>
-              </a:rPr>
-              <a:t>Your health, our mission.</a:t>
-            </a:r>
-          </a:p>
-        </p:txBody>
-      </p:sp>
-      <p:sp>
-        <p:nvSpPr>
-          <p:cNvPr id="8" name="TextBox 7"/>
-          <p:cNvSpPr txBox="1"/>
-          <p:nvPr/>
-        </p:nvSpPr>
-        <p:spPr>
-          <a:xfrm>
-            <a:off x="594360" y="5989320"/>
-            <a:ext cx="10972800" cy="365760"/>
-          </a:xfrm>
-          <a:prstGeom prst="rect">
-            <a:avLst/>
-          </a:prstGeom>
-          <a:noFill/>
-        </p:spPr>
-        <p:txBody>
-          <a:bodyPr wrap="square" anchor="t">
-            <a:spAutoFit/>
-          </a:bodyPr>
-          <a:lstStyle/>
-          <a:p>
-            <a:pPr algn="l">
-              <a:spcAft>
-                <a:spcPts val="0"/>
-              </a:spcAft>
-            </a:pPr>
-            <a:r>
-              <a:rPr sz="1200" b="0" i="0">
-                <a:solidFill>
-                  <a:srgbClr val="D0E8E8"/>
-                </a:solidFill>
-                <a:latin typeface="Calibri"/>
-              </a:rPr>
-              <a:t>Appoint FairBanks youth as AUDA-NEPAD Youth SRH Ambassadors.</a:t>
-            </a:r>
-          </a:p>
-        </p:txBody>
-      </p:sp>
-    </p:spTree>
-  </p:cSld>
-  <p:clrMapOvr>
-    <a:masterClrMapping/>
-  </p:clrMapOvr>
-</p:sld>
-</file>
-
-<file path=ppt/slides/slide10.xml><?xml version="1.0" encoding="utf-8"?>
-<p:sld xmlns:a="http://schemas.openxmlformats.org/drawingml/2006/main" xmlns:p="http://schemas.openxmlformats.org/presentationml/2006/main" xmlns:r="http://schemas.openxmlformats.org/officeDocument/2006/relationships">
-  <p:cSld>
-    <p:spTree>
-      <p:nvGrpSpPr>
-        <p:cNvPr id="1" name=""/>
-        <p:cNvGrpSpPr/>
-        <p:nvPr/>
-      </p:nvGrpSpPr>
-      <p:grpSpPr/>
-      <p:pic>
-        <p:nvPicPr>
-          <p:cNvPr id="2" name="Picture 1" descr="outreach_audience_full_group_01_opt.jpg"/>
-          <p:cNvPicPr>
-            <a:picLocks noChangeAspect="1"/>
-          </p:cNvPicPr>
-          <p:nvPr/>
-        </p:nvPicPr>
-        <p:blipFill>
-          <a:blip r:embed="rId2"/>
-          <a:srcRect t="7796" b="7796"/>
-          <a:stretch>
-            <a:fillRect/>
-          </a:stretch>
-        </p:blipFill>
-        <p:spPr>
-          <a:xfrm>
-            <a:off x="0" y="0"/>
-            <a:ext cx="12191695" cy="6858000"/>
-          </a:xfrm>
-          <a:prstGeom prst="rect">
-            <a:avLst/>
-          </a:prstGeom>
-        </p:spPr>
-      </p:pic>
-      <p:sp>
-        <p:nvSpPr>
-          <p:cNvPr id="3" name="Rectangle 2"/>
-          <p:cNvSpPr/>
-          <p:nvPr/>
-        </p:nvSpPr>
-        <p:spPr>
-          <a:xfrm>
-            <a:off x="0" y="3657600"/>
-            <a:ext cx="12191695" cy="3200400"/>
-          </a:xfrm>
-          <a:prstGeom prst="rect">
-            <a:avLst/>
-          </a:prstGeom>
-          <a:solidFill>
-            <a:srgbClr val="0A1F2E"/>
-          </a:solidFill>
-          <a:ln>
-            <a:noFill/>
-          </a:ln>
-          <a:effectLst/>
-        </p:spPr>
-        <p:style>
-          <a:lnRef idx="1">
-            <a:schemeClr val="accent1"/>
-          </a:lnRef>
-          <a:fillRef idx="3">
-            <a:schemeClr val="accent1"/>
-          </a:fillRef>
-          <a:effectRef idx="2">
-            <a:schemeClr val="accent1"/>
-          </a:effectRef>
-          <a:fontRef idx="minor">
-            <a:schemeClr val="lt1"/>
-          </a:fontRef>
-        </p:style>
-        <p:txBody>
-          <a:bodyPr rtlCol="0" anchor="ctr"/>
-          <a:lstStyle/>
-          <a:p>
-            <a:pPr algn="ctr"/>
-          </a:p>
-        </p:txBody>
-      </p:sp>
-      <p:sp>
-        <p:nvSpPr>
-          <p:cNvPr id="4" name="TextBox 3"/>
-          <p:cNvSpPr txBox="1"/>
-          <p:nvPr/>
-        </p:nvSpPr>
-        <p:spPr>
-          <a:xfrm>
-            <a:off x="594360" y="3931920"/>
-            <a:ext cx="10972800" cy="274320"/>
-          </a:xfrm>
-          <a:prstGeom prst="rect">
-            <a:avLst/>
-          </a:prstGeom>
-          <a:noFill/>
-        </p:spPr>
-        <p:txBody>
-          <a:bodyPr wrap="square" anchor="t">
-            <a:spAutoFit/>
-          </a:bodyPr>
-          <a:lstStyle/>
-          <a:p>
-            <a:pPr algn="l">
-              <a:spcAft>
-                <a:spcPts val="0"/>
-              </a:spcAft>
-            </a:pPr>
-            <a:r>
-              <a:rPr sz="1300" b="1" i="0">
-                <a:solidFill>
-                  <a:srgbClr val="14A3A3"/>
-                </a:solidFill>
-                <a:latin typeface="Calibri"/>
-              </a:rPr>
-              <a:t>The ask</a:t>
-            </a:r>
-          </a:p>
-        </p:txBody>
-      </p:sp>
-      <p:sp>
-        <p:nvSpPr>
-          <p:cNvPr id="5" name="TextBox 4"/>
-          <p:cNvSpPr txBox="1"/>
-          <p:nvPr/>
-        </p:nvSpPr>
-        <p:spPr>
-          <a:xfrm>
-            <a:off x="594360" y="4389120"/>
-            <a:ext cx="10972800" cy="822960"/>
-          </a:xfrm>
-          <a:prstGeom prst="rect">
-            <a:avLst/>
-          </a:prstGeom>
-          <a:noFill/>
-        </p:spPr>
-        <p:txBody>
-          <a:bodyPr wrap="square" anchor="t">
-            <a:spAutoFit/>
-          </a:bodyPr>
-          <a:lstStyle/>
-          <a:p>
-            <a:pPr algn="l">
-              <a:spcAft>
-                <a:spcPts val="0"/>
-              </a:spcAft>
-            </a:pPr>
-            <a:r>
-              <a:rPr sz="2200" b="1" i="0">
-                <a:solidFill>
-                  <a:srgbClr val="FFFFFF"/>
-                </a:solidFill>
-                <a:latin typeface="Calibri"/>
-              </a:rPr>
-              <a:t>Appoint FairBanks youth as AUDA-NEPAD Youth SRH Ambassadors.</a:t>
-            </a:r>
-          </a:p>
-        </p:txBody>
-      </p:sp>
-      <p:sp>
-        <p:nvSpPr>
-          <p:cNvPr id="6" name="TextBox 5"/>
-          <p:cNvSpPr txBox="1"/>
-          <p:nvPr/>
-        </p:nvSpPr>
-        <p:spPr>
-          <a:xfrm>
-            <a:off x="594360" y="5394960"/>
-            <a:ext cx="10972800" cy="365760"/>
-          </a:xfrm>
-          <a:prstGeom prst="rect">
-            <a:avLst/>
-          </a:prstGeom>
-          <a:noFill/>
-        </p:spPr>
-        <p:txBody>
-          <a:bodyPr wrap="square" anchor="t">
-            <a:spAutoFit/>
-          </a:bodyPr>
-          <a:lstStyle/>
-          <a:p>
-            <a:pPr algn="l">
-              <a:spcAft>
-                <a:spcPts val="0"/>
-              </a:spcAft>
-            </a:pPr>
-            <a:r>
-              <a:rPr sz="1400" b="0" i="1">
-                <a:solidFill>
-                  <a:srgbClr val="F2C79B"/>
-                </a:solidFill>
-                <a:latin typeface="Calibri"/>
-              </a:rPr>
-              <a:t>Advocacy and mobilisation powered by FairBanks community reach</a:t>
-            </a:r>
-          </a:p>
-        </p:txBody>
-      </p:sp>
-      <p:sp>
-        <p:nvSpPr>
-          <p:cNvPr id="7" name="TextBox 6"/>
-          <p:cNvSpPr txBox="1"/>
-          <p:nvPr/>
-        </p:nvSpPr>
-        <p:spPr>
-          <a:xfrm>
-            <a:off x="594360" y="5943600"/>
-            <a:ext cx="10972800" cy="320040"/>
-          </a:xfrm>
-          <a:prstGeom prst="rect">
-            <a:avLst/>
-          </a:prstGeom>
-          <a:noFill/>
-        </p:spPr>
-        <p:txBody>
-          <a:bodyPr wrap="square" anchor="t">
-            <a:spAutoFit/>
-          </a:bodyPr>
-          <a:lstStyle/>
-          <a:p>
-            <a:pPr algn="l">
-              <a:spcAft>
-                <a:spcPts val="0"/>
-              </a:spcAft>
-            </a:pPr>
+            <a:pPr algn="l"/>
             <a:r>
               <a:rPr sz="1400" b="1" i="0">
                 <a:solidFill>
@@ -3600,6 +3263,41 @@
                 <a:latin typeface="Calibri"/>
               </a:rPr>
               <a:t>Your health, our mission.</a:t>
+            </a:r>
+          </a:p>
+        </p:txBody>
+      </p:sp>
+      <p:sp>
+        <p:nvSpPr>
+          <p:cNvPr id="7" name="TextBox 6"/>
+          <p:cNvSpPr txBox="1"/>
+          <p:nvPr/>
+        </p:nvSpPr>
+        <p:spPr>
+          <a:xfrm>
+            <a:off x="548640" y="5806440"/>
+            <a:ext cx="10972800" cy="320040"/>
+          </a:xfrm>
+          <a:prstGeom prst="rect">
+            <a:avLst/>
+          </a:prstGeom>
+          <a:noFill/>
+        </p:spPr>
+        <p:txBody>
+          <a:bodyPr wrap="square">
+            <a:spAutoFit/>
+          </a:bodyPr>
+          <a:lstStyle/>
+          <a:p>
+            <a:pPr algn="l"/>
+            <a:r>
+              <a:rPr sz="1200" b="1" i="0">
+                <a:solidFill>
+                  <a:srgbClr val="F2C79B"/>
+                </a:solidFill>
+                <a:latin typeface="Calibri"/>
+              </a:rPr>
+              <a:t>Application deadline: 17 July 2026</a:t>
             </a:r>
           </a:p>
         </p:txBody>
@@ -3631,7 +3329,7 @@
         <p:spPr>
           <a:xfrm>
             <a:off x="0" y="0"/>
-            <a:ext cx="12191695" cy="960120"/>
+            <a:ext cx="12191695" cy="914400"/>
           </a:xfrm>
           <a:prstGeom prst="rect">
             <a:avLst/>
@@ -3642,7 +3340,6 @@
           <a:ln>
             <a:noFill/>
           </a:ln>
-          <a:effectLst/>
         </p:spPr>
         <p:style>
           <a:lnRef idx="1">
@@ -3675,7 +3372,7 @@
         <p:spPr>
           <a:xfrm>
             <a:off x="0" y="0"/>
-            <a:ext cx="164592" cy="960120"/>
+            <a:ext cx="137160" cy="914400"/>
           </a:xfrm>
           <a:prstGeom prst="rect">
             <a:avLst/>
@@ -3686,7 +3383,6 @@
           <a:ln>
             <a:noFill/>
           </a:ln>
-          <a:effectLst/>
         </p:spPr>
         <p:style>
           <a:lnRef idx="1">
@@ -3718,8 +3414,8 @@
         </p:nvSpPr>
         <p:spPr>
           <a:xfrm>
-            <a:off x="457200" y="109728"/>
-            <a:ext cx="10972800" cy="256032"/>
+            <a:off x="411480" y="91440"/>
+            <a:ext cx="10972800" cy="274320"/>
           </a:xfrm>
           <a:prstGeom prst="rect">
             <a:avLst/>
@@ -3727,16 +3423,12 @@
           <a:noFill/>
         </p:spPr>
         <p:txBody>
-          <a:bodyPr wrap="square" anchor="t">
+          <a:bodyPr wrap="square">
             <a:spAutoFit/>
           </a:bodyPr>
           <a:lstStyle/>
           <a:p>
-            <a:pPr algn="l">
-              <a:spcAft>
-                <a:spcPts val="0"/>
-              </a:spcAft>
-            </a:pPr>
+            <a:pPr algn="l"/>
             <a:r>
               <a:rPr sz="1100" b="1" i="0">
                 <a:solidFill>
@@ -3744,7 +3436,7 @@
                 </a:solidFill>
                 <a:latin typeface="Calibri"/>
               </a:rPr>
-              <a:t>WIN-WIN</a:t>
+              <a:t>NOMINATION</a:t>
             </a:r>
           </a:p>
         </p:txBody>
@@ -3757,8 +3449,8 @@
         </p:nvSpPr>
         <p:spPr>
           <a:xfrm>
-            <a:off x="457200" y="384048"/>
-            <a:ext cx="11247120" cy="475488"/>
+            <a:off x="411480" y="384048"/>
+            <a:ext cx="10972800" cy="457200"/>
           </a:xfrm>
           <a:prstGeom prst="rect">
             <a:avLst/>
@@ -3766,24 +3458,20 @@
           <a:noFill/>
         </p:spPr>
         <p:txBody>
-          <a:bodyPr wrap="square" anchor="t">
+          <a:bodyPr wrap="square">
             <a:spAutoFit/>
           </a:bodyPr>
           <a:lstStyle/>
           <a:p>
-            <a:pPr algn="l">
-              <a:spcAft>
-                <a:spcPts val="0"/>
-              </a:spcAft>
-            </a:pPr>
-            <a:r>
-              <a:rPr sz="2200" b="1" i="0">
+            <a:pPr algn="l"/>
+            <a:r>
+              <a:rPr sz="2400" b="1" i="0">
                 <a:solidFill>
                   <a:srgbClr val="0A1F2E"/>
                 </a:solidFill>
                 <a:latin typeface="Calibri"/>
               </a:rPr>
-              <a:t>Mutual value for FairBanks and the programme</a:t>
+              <a:t>Grassroots mobiliser → continental SRH voice</a:t>
             </a:r>
           </a:p>
         </p:txBody>
@@ -3796,47 +3484,8 @@
         </p:nvSpPr>
         <p:spPr>
           <a:xfrm>
-            <a:off x="457200" y="1143000"/>
-            <a:ext cx="5486400" cy="320040"/>
-          </a:xfrm>
-          <a:prstGeom prst="rect">
-            <a:avLst/>
-          </a:prstGeom>
-          <a:noFill/>
-        </p:spPr>
-        <p:txBody>
-          <a:bodyPr wrap="square" anchor="t">
-            <a:spAutoFit/>
-          </a:bodyPr>
-          <a:lstStyle/>
-          <a:p>
-            <a:pPr algn="l">
-              <a:spcAft>
-                <a:spcPts val="0"/>
-              </a:spcAft>
-            </a:pPr>
-            <a:r>
-              <a:rPr sz="1600" b="1" i="0">
-                <a:solidFill>
-                  <a:srgbClr val="0D6E6E"/>
-                </a:solidFill>
-                <a:latin typeface="Calibri"/>
-              </a:rPr>
-              <a:t>What we gain</a:t>
-            </a:r>
-          </a:p>
-        </p:txBody>
-      </p:sp>
-      <p:sp>
-        <p:nvSpPr>
-          <p:cNvPr id="7" name="TextBox 6"/>
-          <p:cNvSpPr txBox="1"/>
-          <p:nvPr/>
-        </p:nvSpPr>
-        <p:spPr>
-          <a:xfrm>
-            <a:off x="457200" y="1508760"/>
-            <a:ext cx="5486400" cy="4800600"/>
+            <a:off x="457200" y="1097280"/>
+            <a:ext cx="10972800" cy="5029200"/>
           </a:xfrm>
           <a:prstGeom prst="rect">
             <a:avLst/>
@@ -3849,207 +3498,31 @@
           </a:bodyPr>
           <a:lstStyle/>
           <a:p>
-            <a:pPr>
-              <a:spcAft>
-                <a:spcPts val="800"/>
-              </a:spcAft>
-            </a:pPr>
-            <a:r>
-              <a:rPr sz="1300">
+            <a:pPr algn="l"/>
+            <a:r>
+              <a:rPr sz="1800" b="0" i="0">
                 <a:solidFill>
                   <a:srgbClr val="1E2F38"/>
                 </a:solidFill>
                 <a:latin typeface="Calibri"/>
               </a:rPr>
-              <a:t>•  Continental recognition and mentorship for FairBanks youth</a:t>
-            </a:r>
-          </a:p>
-          <a:p>
-            <a:pPr>
-              <a:spcAft>
-                <a:spcPts val="800"/>
-              </a:spcAft>
-            </a:pPr>
-            <a:r>
-              <a:rPr sz="1300">
-                <a:solidFill>
-                  <a:srgbClr val="1E2F38"/>
-                </a:solidFill>
-                <a:latin typeface="Calibri"/>
-              </a:rPr>
-              <a:t>•  Training that strengthens our adolescent and maternal health messaging</a:t>
-            </a:r>
-          </a:p>
-          <a:p>
-            <a:pPr>
-              <a:spcAft>
-                <a:spcPts val="800"/>
-              </a:spcAft>
-            </a:pPr>
-            <a:r>
-              <a:rPr sz="1300">
-                <a:solidFill>
-                  <a:srgbClr val="1E2F38"/>
-                </a:solidFill>
-                <a:latin typeface="Calibri"/>
-              </a:rPr>
-              <a:t>•  Network access across African Union youth health spaces</a:t>
-            </a:r>
-          </a:p>
-          <a:p>
-            <a:pPr>
-              <a:spcAft>
-                <a:spcPts val="800"/>
-              </a:spcAft>
-            </a:pPr>
-            <a:r>
-              <a:rPr sz="1300">
-                <a:solidFill>
-                  <a:srgbClr val="1E2F38"/>
-                </a:solidFill>
-                <a:latin typeface="Calibri"/>
-              </a:rPr>
-              <a:t>•  Sponsored participation opportunities in selected events</a:t>
-            </a:r>
-          </a:p>
-        </p:txBody>
-      </p:sp>
-      <p:sp>
-        <p:nvSpPr>
-          <p:cNvPr id="8" name="TextBox 7"/>
-          <p:cNvSpPr txBox="1"/>
-          <p:nvPr/>
-        </p:nvSpPr>
-        <p:spPr>
-          <a:xfrm>
-            <a:off x="6309360" y="1143000"/>
-            <a:ext cx="5486400" cy="320040"/>
-          </a:xfrm>
-          <a:prstGeom prst="rect">
-            <a:avLst/>
-          </a:prstGeom>
-          <a:noFill/>
-        </p:spPr>
-        <p:txBody>
-          <a:bodyPr wrap="square" anchor="t">
-            <a:spAutoFit/>
-          </a:bodyPr>
-          <a:lstStyle/>
-          <a:p>
-            <a:pPr algn="l">
-              <a:spcAft>
-                <a:spcPts val="0"/>
-              </a:spcAft>
-            </a:pPr>
-            <a:r>
-              <a:rPr sz="1600" b="1" i="0">
-                <a:solidFill>
-                  <a:srgbClr val="0D6E6E"/>
-                </a:solidFill>
-                <a:latin typeface="Calibri"/>
-              </a:rPr>
-              <a:t>What they gain</a:t>
-            </a:r>
-          </a:p>
-        </p:txBody>
-      </p:sp>
-      <p:sp>
-        <p:nvSpPr>
-          <p:cNvPr id="9" name="TextBox 8"/>
-          <p:cNvSpPr txBox="1"/>
-          <p:nvPr/>
-        </p:nvSpPr>
-        <p:spPr>
-          <a:xfrm>
-            <a:off x="6309360" y="1508760"/>
-            <a:ext cx="5394960" cy="4800600"/>
-          </a:xfrm>
-          <a:prstGeom prst="rect">
-            <a:avLst/>
-          </a:prstGeom>
-          <a:noFill/>
-        </p:spPr>
-        <p:txBody>
-          <a:bodyPr wrap="square">
-            <a:spAutoFit/>
-          </a:bodyPr>
-          <a:lstStyle/>
-          <a:p>
-            <a:pPr>
-              <a:spcAft>
-                <a:spcPts val="800"/>
-              </a:spcAft>
-            </a:pPr>
-            <a:r>
-              <a:rPr sz="1300">
-                <a:solidFill>
-                  <a:srgbClr val="1E2F38"/>
-                </a:solidFill>
-                <a:latin typeface="Calibri"/>
-              </a:rPr>
-              <a:t>•  Ambassadors embedded in a live community health organisation</a:t>
-            </a:r>
-          </a:p>
-          <a:p>
-            <a:pPr>
-              <a:spcAft>
-                <a:spcPts val="800"/>
-              </a:spcAft>
-            </a:pPr>
-            <a:r>
-              <a:rPr sz="1300">
-                <a:solidFill>
-                  <a:srgbClr val="1E2F38"/>
-                </a:solidFill>
-                <a:latin typeface="Calibri"/>
-              </a:rPr>
-              <a:t>•  Channels to CHWs, schools, and outreach events in Kampala communities</a:t>
-            </a:r>
-          </a:p>
-          <a:p>
-            <a:pPr>
-              <a:spcAft>
-                <a:spcPts val="800"/>
-              </a:spcAft>
-            </a:pPr>
-            <a:r>
-              <a:rPr sz="1300">
-                <a:solidFill>
-                  <a:srgbClr val="1E2F38"/>
-                </a:solidFill>
-                <a:latin typeface="Calibri"/>
-              </a:rPr>
-              <a:t>•  Digital storytelling grounded in real SRH service pathways</a:t>
-            </a:r>
-          </a:p>
-          <a:p>
-            <a:pPr>
-              <a:spcAft>
-                <a:spcPts val="800"/>
-              </a:spcAft>
-            </a:pPr>
-            <a:r>
-              <a:rPr sz="1300">
-                <a:solidFill>
-                  <a:srgbClr val="1E2F38"/>
-                </a:solidFill>
-                <a:latin typeface="Calibri"/>
-              </a:rPr>
-              <a:t>•  Diverse regional representation from East Africa / Uganda</a:t>
-            </a:r>
-          </a:p>
-        </p:txBody>
-      </p:sp>
-      <p:sp>
-        <p:nvSpPr>
-          <p:cNvPr id="10" name="Rectangle 9"/>
+              <a:t>FairBanks Community Reach runs maternal &amp; adolescent programmes with CHWs/VHTs.
+Ambassadors must connect field truth to policy — that is already my work.
+FCHIP adds evidence on where SRH gaps cluster.</a:t>
+            </a:r>
+          </a:p>
+        </p:txBody>
+      </p:sp>
+      <p:sp>
+        <p:nvSpPr>
+          <p:cNvPr id="7" name="Rectangle 6"/>
           <p:cNvSpPr/>
           <p:nvPr/>
         </p:nvSpPr>
         <p:spPr>
           <a:xfrm>
-            <a:off x="0" y="6565392"/>
-            <a:ext cx="12191695" cy="292608"/>
+            <a:off x="0" y="6583680"/>
+            <a:ext cx="12191695" cy="274320"/>
           </a:xfrm>
           <a:prstGeom prst="rect">
             <a:avLst/>
@@ -4060,7 +3533,6 @@
           <a:ln>
             <a:noFill/>
           </a:ln>
-          <a:effectLst/>
         </p:spPr>
         <p:style>
           <a:lnRef idx="1">
@@ -4086,14 +3558,14 @@
       </p:sp>
       <p:sp>
         <p:nvSpPr>
-          <p:cNvPr id="11" name="TextBox 10"/>
+          <p:cNvPr id="8" name="TextBox 7"/>
           <p:cNvSpPr txBox="1"/>
           <p:nvPr/>
         </p:nvSpPr>
         <p:spPr>
           <a:xfrm>
-            <a:off x="365760" y="6574536"/>
-            <a:ext cx="9144000" cy="274320"/>
+            <a:off x="365760" y="6592824"/>
+            <a:ext cx="9144000" cy="256032"/>
           </a:xfrm>
           <a:prstGeom prst="rect">
             <a:avLst/>
@@ -4101,16 +3573,12 @@
           <a:noFill/>
         </p:spPr>
         <p:txBody>
-          <a:bodyPr wrap="square" anchor="ctr">
+          <a:bodyPr wrap="square">
             <a:spAutoFit/>
           </a:bodyPr>
           <a:lstStyle/>
           <a:p>
-            <a:pPr algn="l">
-              <a:spcAft>
-                <a:spcPts val="0"/>
-              </a:spcAft>
-            </a:pPr>
+            <a:pPr algn="l"/>
             <a:r>
               <a:rPr sz="900" b="0" i="0">
                 <a:solidFill>
@@ -4118,21 +3586,21 @@
                 </a:solidFill>
                 <a:latin typeface="Calibri"/>
               </a:rPr>
-              <a:t>FairBanks FCHIP  |  AUDA-NEPAD Youth SRH Ambassadors Initiat  |  Your health, our mission.</a:t>
-            </a:r>
-          </a:p>
-        </p:txBody>
-      </p:sp>
-      <p:sp>
-        <p:nvSpPr>
-          <p:cNvPr id="12" name="TextBox 11"/>
+              <a:t>FairBanks | AUDA-NEPAD Youth SRH Ambassador | Your health, our mission.</a:t>
+            </a:r>
+          </a:p>
+        </p:txBody>
+      </p:sp>
+      <p:sp>
+        <p:nvSpPr>
+          <p:cNvPr id="9" name="TextBox 8"/>
           <p:cNvSpPr txBox="1"/>
           <p:nvPr/>
         </p:nvSpPr>
         <p:spPr>
           <a:xfrm>
-            <a:off x="11094415" y="6574536"/>
-            <a:ext cx="731520" cy="274320"/>
+            <a:off x="11460175" y="6592824"/>
+            <a:ext cx="457200" cy="256032"/>
           </a:xfrm>
           <a:prstGeom prst="rect">
             <a:avLst/>
@@ -4140,16 +3608,12 @@
           <a:noFill/>
         </p:spPr>
         <p:txBody>
-          <a:bodyPr wrap="square" anchor="ctr">
+          <a:bodyPr wrap="square">
             <a:spAutoFit/>
           </a:bodyPr>
           <a:lstStyle/>
           <a:p>
-            <a:pPr algn="r">
-              <a:spcAft>
-                <a:spcPts val="0"/>
-              </a:spcAft>
-            </a:pPr>
+            <a:pPr algn="r"/>
             <a:r>
               <a:rPr sz="900" b="0" i="0">
                 <a:solidFill>
@@ -4189,7 +3653,7 @@
         <p:spPr>
           <a:xfrm>
             <a:off x="0" y="0"/>
-            <a:ext cx="12191695" cy="960120"/>
+            <a:ext cx="12191695" cy="914400"/>
           </a:xfrm>
           <a:prstGeom prst="rect">
             <a:avLst/>
@@ -4200,7 +3664,6 @@
           <a:ln>
             <a:noFill/>
           </a:ln>
-          <a:effectLst/>
         </p:spPr>
         <p:style>
           <a:lnRef idx="1">
@@ -4233,7 +3696,7 @@
         <p:spPr>
           <a:xfrm>
             <a:off x="0" y="0"/>
-            <a:ext cx="164592" cy="960120"/>
+            <a:ext cx="137160" cy="914400"/>
           </a:xfrm>
           <a:prstGeom prst="rect">
             <a:avLst/>
@@ -4244,7 +3707,6 @@
           <a:ln>
             <a:noFill/>
           </a:ln>
-          <a:effectLst/>
         </p:spPr>
         <p:style>
           <a:lnRef idx="1">
@@ -4276,8 +3738,8 @@
         </p:nvSpPr>
         <p:spPr>
           <a:xfrm>
-            <a:off x="457200" y="109728"/>
-            <a:ext cx="10972800" cy="256032"/>
+            <a:off x="411480" y="91440"/>
+            <a:ext cx="10972800" cy="274320"/>
           </a:xfrm>
           <a:prstGeom prst="rect">
             <a:avLst/>
@@ -4285,16 +3747,12 @@
           <a:noFill/>
         </p:spPr>
         <p:txBody>
-          <a:bodyPr wrap="square" anchor="t">
+          <a:bodyPr wrap="square">
             <a:spAutoFit/>
           </a:bodyPr>
           <a:lstStyle/>
           <a:p>
-            <a:pPr algn="l">
-              <a:spcAft>
-                <a:spcPts val="0"/>
-              </a:spcAft>
-            </a:pPr>
+            <a:pPr algn="l"/>
             <a:r>
               <a:rPr sz="1100" b="1" i="0">
                 <a:solidFill>
@@ -4302,7 +3760,7 @@
                 </a:solidFill>
                 <a:latin typeface="Calibri"/>
               </a:rPr>
-              <a:t>THE PROBLEM</a:t>
+              <a:t>ADVOCACY</a:t>
             </a:r>
           </a:p>
         </p:txBody>
@@ -4315,8 +3773,8 @@
         </p:nvSpPr>
         <p:spPr>
           <a:xfrm>
-            <a:off x="457200" y="384048"/>
-            <a:ext cx="11247120" cy="475488"/>
+            <a:off x="411480" y="384048"/>
+            <a:ext cx="10972800" cy="457200"/>
           </a:xfrm>
           <a:prstGeom prst="rect">
             <a:avLst/>
@@ -4324,31 +3782,27 @@
           <a:noFill/>
         </p:spPr>
         <p:txBody>
-          <a:bodyPr wrap="square" anchor="t">
+          <a:bodyPr wrap="square">
             <a:spAutoFit/>
           </a:bodyPr>
           <a:lstStyle/>
           <a:p>
-            <a:pPr algn="l">
-              <a:spcAft>
-                <a:spcPts val="0"/>
-              </a:spcAft>
-            </a:pPr>
-            <a:r>
-              <a:rPr sz="2200" b="1" i="0">
+            <a:pPr algn="l"/>
+            <a:r>
+              <a:rPr sz="2400" b="1" i="0">
                 <a:solidFill>
                   <a:srgbClr val="0A1F2E"/>
                 </a:solidFill>
                 <a:latin typeface="Calibri"/>
               </a:rPr>
-              <a:t>Health systems react too late</a:t>
+              <a:t>SRH through FairBanks outreach</a:t>
             </a:r>
           </a:p>
         </p:txBody>
       </p:sp>
       <p:pic>
         <p:nvPicPr>
-          <p:cNvPr id="6" name="Picture 5" descr="reactive_clinic_opt.jpg"/>
+          <p:cNvPr id="6" name="Picture 5" descr="outreach_facilitator_canopy_01_opt.jpg"/>
           <p:cNvPicPr>
             <a:picLocks noChangeAspect="1"/>
           </p:cNvPicPr>
@@ -4362,7 +3816,7 @@
         </p:blipFill>
         <p:spPr>
           <a:xfrm>
-            <a:off x="411480" y="2004691"/>
+            <a:off x="411480" y="1844671"/>
             <a:ext cx="5303520" cy="3534417"/>
           </a:xfrm>
           <a:prstGeom prst="rect">
@@ -4378,8 +3832,8 @@
         </p:nvSpPr>
         <p:spPr>
           <a:xfrm>
-            <a:off x="6035040" y="1234440"/>
-            <a:ext cx="5669280" cy="5074920"/>
+            <a:off x="5943600" y="1097280"/>
+            <a:ext cx="5760720" cy="5029200"/>
           </a:xfrm>
           <a:prstGeom prst="rect">
             <a:avLst/>
@@ -4392,83 +3846,18 @@
           </a:bodyPr>
           <a:lstStyle/>
           <a:p>
-            <a:pPr>
-              <a:spcAft>
-                <a:spcPts val="800"/>
-              </a:spcAft>
-            </a:pPr>
-            <a:r>
-              <a:rPr sz="1400">
+            <a:pPr algn="l"/>
+            <a:r>
+              <a:rPr sz="1500" b="0" i="0">
                 <a:solidFill>
                   <a:srgbClr val="1E2F38"/>
                 </a:solidFill>
                 <a:latin typeface="Calibri"/>
               </a:rPr>
-              <a:t>•  Care often starts only after people fall sick</a:t>
-            </a:r>
-          </a:p>
-          <a:p>
-            <a:pPr>
-              <a:spcAft>
-                <a:spcPts val="800"/>
-              </a:spcAft>
-            </a:pPr>
-            <a:r>
-              <a:rPr sz="1400">
-                <a:solidFill>
-                  <a:srgbClr val="1E2F38"/>
-                </a:solidFill>
-                <a:latin typeface="Calibri"/>
-              </a:rPr>
-              <a:t>•  Community health data sits in paper registers and silos</a:t>
-            </a:r>
-          </a:p>
-          <a:p>
-            <a:pPr>
-              <a:spcAft>
-                <a:spcPts val="800"/>
-              </a:spcAft>
-            </a:pPr>
-            <a:r>
-              <a:rPr sz="1400">
-                <a:solidFill>
-                  <a:srgbClr val="1E2F38"/>
-                </a:solidFill>
-                <a:latin typeface="Calibri"/>
-              </a:rPr>
-              <a:t>•  High-risk pregnancies and NCDs are found too late</a:t>
-            </a:r>
-          </a:p>
-          <a:p>
-            <a:pPr>
-              <a:spcAft>
-                <a:spcPts val="800"/>
-              </a:spcAft>
-            </a:pPr>
-            <a:r>
-              <a:rPr sz="1400">
-                <a:solidFill>
-                  <a:srgbClr val="1E2F38"/>
-                </a:solidFill>
-                <a:latin typeface="Calibri"/>
-              </a:rPr>
-              <a:t>•  Medicine stock-outs hit hard during disease surges</a:t>
-            </a:r>
-          </a:p>
-          <a:p>
-            <a:pPr>
-              <a:spcAft>
-                <a:spcPts val="800"/>
-              </a:spcAft>
-            </a:pPr>
-            <a:r>
-              <a:rPr sz="1400">
-                <a:solidFill>
-                  <a:srgbClr val="1E2F38"/>
-                </a:solidFill>
-                <a:latin typeface="Calibri"/>
-              </a:rPr>
-              <a:t>•  Health shocks push poor families deeper into hardship</a:t>
+              <a:t>• School and community dialogues on adolescent SRH through FairBanks outreach
+• Maternal health education linking ANC uptake, safe pregnancy, and partner involvement
+• Digital content that meets young people where they are — without shame or jargon
+• Peer mobilisation through CHWs/VHTs who already hold community trust</a:t>
             </a:r>
           </a:p>
         </p:txBody>
@@ -4481,8 +3870,8 @@
         </p:nvSpPr>
         <p:spPr>
           <a:xfrm>
-            <a:off x="0" y="6565392"/>
-            <a:ext cx="12191695" cy="292608"/>
+            <a:off x="0" y="6583680"/>
+            <a:ext cx="12191695" cy="274320"/>
           </a:xfrm>
           <a:prstGeom prst="rect">
             <a:avLst/>
@@ -4493,7 +3882,6 @@
           <a:ln>
             <a:noFill/>
           </a:ln>
-          <a:effectLst/>
         </p:spPr>
         <p:style>
           <a:lnRef idx="1">
@@ -4525,8 +3913,8 @@
         </p:nvSpPr>
         <p:spPr>
           <a:xfrm>
-            <a:off x="365760" y="6574536"/>
-            <a:ext cx="9144000" cy="274320"/>
+            <a:off x="365760" y="6592824"/>
+            <a:ext cx="9144000" cy="256032"/>
           </a:xfrm>
           <a:prstGeom prst="rect">
             <a:avLst/>
@@ -4534,16 +3922,12 @@
           <a:noFill/>
         </p:spPr>
         <p:txBody>
-          <a:bodyPr wrap="square" anchor="ctr">
+          <a:bodyPr wrap="square">
             <a:spAutoFit/>
           </a:bodyPr>
           <a:lstStyle/>
           <a:p>
-            <a:pPr algn="l">
-              <a:spcAft>
-                <a:spcPts val="0"/>
-              </a:spcAft>
-            </a:pPr>
+            <a:pPr algn="l"/>
             <a:r>
               <a:rPr sz="900" b="0" i="0">
                 <a:solidFill>
@@ -4551,7 +3935,7 @@
                 </a:solidFill>
                 <a:latin typeface="Calibri"/>
               </a:rPr>
-              <a:t>FairBanks FCHIP  |  AUDA-NEPAD Youth SRH Ambassadors Initiat  |  Your health, our mission.</a:t>
+              <a:t>FairBanks | AUDA-NEPAD Youth SRH Ambassador | Your health, our mission.</a:t>
             </a:r>
           </a:p>
         </p:txBody>
@@ -4564,8 +3948,8 @@
         </p:nvSpPr>
         <p:spPr>
           <a:xfrm>
-            <a:off x="11094415" y="6574536"/>
-            <a:ext cx="731520" cy="274320"/>
+            <a:off x="11460175" y="6592824"/>
+            <a:ext cx="457200" cy="256032"/>
           </a:xfrm>
           <a:prstGeom prst="rect">
             <a:avLst/>
@@ -4573,16 +3957,12 @@
           <a:noFill/>
         </p:spPr>
         <p:txBody>
-          <a:bodyPr wrap="square" anchor="ctr">
+          <a:bodyPr wrap="square">
             <a:spAutoFit/>
           </a:bodyPr>
           <a:lstStyle/>
           <a:p>
-            <a:pPr algn="r">
-              <a:spcAft>
-                <a:spcPts val="0"/>
-              </a:spcAft>
-            </a:pPr>
+            <a:pPr algn="r"/>
             <a:r>
               <a:rPr sz="900" b="0" i="0">
                 <a:solidFill>
@@ -4622,7 +4002,7 @@
         <p:spPr>
           <a:xfrm>
             <a:off x="0" y="0"/>
-            <a:ext cx="12191695" cy="960120"/>
+            <a:ext cx="12191695" cy="914400"/>
           </a:xfrm>
           <a:prstGeom prst="rect">
             <a:avLst/>
@@ -4633,7 +4013,6 @@
           <a:ln>
             <a:noFill/>
           </a:ln>
-          <a:effectLst/>
         </p:spPr>
         <p:style>
           <a:lnRef idx="1">
@@ -4666,7 +4045,7 @@
         <p:spPr>
           <a:xfrm>
             <a:off x="0" y="0"/>
-            <a:ext cx="164592" cy="960120"/>
+            <a:ext cx="137160" cy="914400"/>
           </a:xfrm>
           <a:prstGeom prst="rect">
             <a:avLst/>
@@ -4677,7 +4056,6 @@
           <a:ln>
             <a:noFill/>
           </a:ln>
-          <a:effectLst/>
         </p:spPr>
         <p:style>
           <a:lnRef idx="1">
@@ -4709,8 +4087,8 @@
         </p:nvSpPr>
         <p:spPr>
           <a:xfrm>
-            <a:off x="457200" y="109728"/>
-            <a:ext cx="10972800" cy="256032"/>
+            <a:off x="411480" y="91440"/>
+            <a:ext cx="10972800" cy="274320"/>
           </a:xfrm>
           <a:prstGeom prst="rect">
             <a:avLst/>
@@ -4718,16 +4096,12 @@
           <a:noFill/>
         </p:spPr>
         <p:txBody>
-          <a:bodyPr wrap="square" anchor="t">
+          <a:bodyPr wrap="square">
             <a:spAutoFit/>
           </a:bodyPr>
           <a:lstStyle/>
           <a:p>
-            <a:pPr algn="l">
-              <a:spcAft>
-                <a:spcPts val="0"/>
-              </a:spcAft>
-            </a:pPr>
+            <a:pPr algn="l"/>
             <a:r>
               <a:rPr sz="1100" b="1" i="0">
                 <a:solidFill>
@@ -4735,7 +4109,7 @@
                 </a:solidFill>
                 <a:latin typeface="Calibri"/>
               </a:rPr>
-              <a:t>THE SOLUTION</a:t>
+              <a:t>MOBILISATION</a:t>
             </a:r>
           </a:p>
         </p:txBody>
@@ -4748,8 +4122,8 @@
         </p:nvSpPr>
         <p:spPr>
           <a:xfrm>
-            <a:off x="457200" y="384048"/>
-            <a:ext cx="11247120" cy="475488"/>
+            <a:off x="411480" y="384048"/>
+            <a:ext cx="10972800" cy="457200"/>
           </a:xfrm>
           <a:prstGeom prst="rect">
             <a:avLst/>
@@ -4757,31 +4131,27 @@
           <a:noFill/>
         </p:spPr>
         <p:txBody>
-          <a:bodyPr wrap="square" anchor="t">
+          <a:bodyPr wrap="square">
             <a:spAutoFit/>
           </a:bodyPr>
           <a:lstStyle/>
           <a:p>
-            <a:pPr algn="l">
-              <a:spcAft>
-                <a:spcPts val="0"/>
-              </a:spcAft>
-            </a:pPr>
-            <a:r>
-              <a:rPr sz="2200" b="1" i="0">
+            <a:pPr algn="l"/>
+            <a:r>
+              <a:rPr sz="2400" b="1" i="0">
                 <a:solidFill>
                   <a:srgbClr val="0A1F2E"/>
                 </a:solidFill>
                 <a:latin typeface="Calibri"/>
               </a:rPr>
-              <a:t>FCHIP — community health intelligence</a:t>
+              <a:t>Kampala communities — dialogue first</a:t>
             </a:r>
           </a:p>
         </p:txBody>
       </p:sp>
       <p:pic>
         <p:nvPicPr>
-          <p:cNvPr id="6" name="Picture 5" descr="data_flow_iso_labeled_opt.jpg"/>
+          <p:cNvPr id="6" name="Picture 5" descr="outreach_audience_discussion_01_opt.jpg"/>
           <p:cNvPicPr>
             <a:picLocks noChangeAspect="1"/>
           </p:cNvPicPr>
@@ -4795,8 +4165,8 @@
         </p:blipFill>
         <p:spPr>
           <a:xfrm>
-            <a:off x="365760" y="1639062"/>
-            <a:ext cx="6400800" cy="4265676"/>
+            <a:off x="411480" y="1783080"/>
+            <a:ext cx="5486400" cy="3657600"/>
           </a:xfrm>
           <a:prstGeom prst="rect">
             <a:avLst/>
@@ -4811,8 +4181,8 @@
         </p:nvSpPr>
         <p:spPr>
           <a:xfrm>
-            <a:off x="7040880" y="1234440"/>
-            <a:ext cx="4754880" cy="5074920"/>
+            <a:off x="6217920" y="1097280"/>
+            <a:ext cx="5486400" cy="5029200"/>
           </a:xfrm>
           <a:prstGeom prst="rect">
             <a:avLst/>
@@ -4825,67 +4195,17 @@
           </a:bodyPr>
           <a:lstStyle/>
           <a:p>
-            <a:pPr>
-              <a:spcAft>
-                <a:spcPts val="800"/>
-              </a:spcAft>
-            </a:pPr>
-            <a:r>
-              <a:rPr sz="1400">
+            <a:pPr algn="l"/>
+            <a:r>
+              <a:rPr sz="1600" b="0" i="0">
                 <a:solidFill>
-                  <a:srgbClr val="1E2F38"/>
+                  <a:srgbClr val="3A4A54"/>
                 </a:solidFill>
                 <a:latin typeface="Calibri"/>
               </a:rPr>
-              <a:t>•  CHWs and VHTs capture structured data at household level</a:t>
-            </a:r>
-          </a:p>
-          <a:p>
-            <a:pPr>
-              <a:spcAft>
-                <a:spcPts val="800"/>
-              </a:spcAft>
-            </a:pPr>
-            <a:r>
-              <a:rPr sz="1400">
-                <a:solidFill>
-                  <a:srgbClr val="1E2F38"/>
-                </a:solidFill>
-                <a:latin typeface="Calibri"/>
-              </a:rPr>
-              <a:t>•  FCHIP applies AI, ML, and GIS to predict risk early</a:t>
-            </a:r>
-          </a:p>
-          <a:p>
-            <a:pPr>
-              <a:spcAft>
-                <a:spcPts val="800"/>
-              </a:spcAft>
-            </a:pPr>
-            <a:r>
-              <a:rPr sz="1400">
-                <a:solidFill>
-                  <a:srgbClr val="1E2F38"/>
-                </a:solidFill>
-                <a:latin typeface="Calibri"/>
-              </a:rPr>
-              <a:t>•  Alerts reach clinics, districts, and partners in time to act</a:t>
-            </a:r>
-          </a:p>
-          <a:p>
-            <a:pPr>
-              <a:spcAft>
-                <a:spcPts val="800"/>
-              </a:spcAft>
-            </a:pPr>
-            <a:r>
-              <a:rPr sz="1400">
-                <a:solidFill>
-                  <a:srgbClr val="1E2F38"/>
-                </a:solidFill>
-                <a:latin typeface="Calibri"/>
-              </a:rPr>
-              <a:t>•  Built on a live medical centre and community programmes</a:t>
+              <a:t>Bukoto · Kyebando · Kisaasi · Kamwokya · Kikaaya
+CHWs translate SRH into trusted local action
+Digital + in-person — no shame, no jargon</a:t>
             </a:r>
           </a:p>
         </p:txBody>
@@ -4898,8 +4218,8 @@
         </p:nvSpPr>
         <p:spPr>
           <a:xfrm>
-            <a:off x="0" y="6565392"/>
-            <a:ext cx="12191695" cy="292608"/>
+            <a:off x="0" y="6583680"/>
+            <a:ext cx="12191695" cy="274320"/>
           </a:xfrm>
           <a:prstGeom prst="rect">
             <a:avLst/>
@@ -4910,7 +4230,6 @@
           <a:ln>
             <a:noFill/>
           </a:ln>
-          <a:effectLst/>
         </p:spPr>
         <p:style>
           <a:lnRef idx="1">
@@ -4942,8 +4261,8 @@
         </p:nvSpPr>
         <p:spPr>
           <a:xfrm>
-            <a:off x="365760" y="6574536"/>
-            <a:ext cx="9144000" cy="274320"/>
+            <a:off x="365760" y="6592824"/>
+            <a:ext cx="9144000" cy="256032"/>
           </a:xfrm>
           <a:prstGeom prst="rect">
             <a:avLst/>
@@ -4951,16 +4270,12 @@
           <a:noFill/>
         </p:spPr>
         <p:txBody>
-          <a:bodyPr wrap="square" anchor="ctr">
+          <a:bodyPr wrap="square">
             <a:spAutoFit/>
           </a:bodyPr>
           <a:lstStyle/>
           <a:p>
-            <a:pPr algn="l">
-              <a:spcAft>
-                <a:spcPts val="0"/>
-              </a:spcAft>
-            </a:pPr>
+            <a:pPr algn="l"/>
             <a:r>
               <a:rPr sz="900" b="0" i="0">
                 <a:solidFill>
@@ -4968,7 +4283,7 @@
                 </a:solidFill>
                 <a:latin typeface="Calibri"/>
               </a:rPr>
-              <a:t>FairBanks FCHIP  |  AUDA-NEPAD Youth SRH Ambassadors Initiat  |  Your health, our mission.</a:t>
+              <a:t>FairBanks | AUDA-NEPAD Youth SRH Ambassador | Your health, our mission.</a:t>
             </a:r>
           </a:p>
         </p:txBody>
@@ -4981,8 +4296,8 @@
         </p:nvSpPr>
         <p:spPr>
           <a:xfrm>
-            <a:off x="11094415" y="6574536"/>
-            <a:ext cx="731520" cy="274320"/>
+            <a:off x="11460175" y="6592824"/>
+            <a:ext cx="457200" cy="256032"/>
           </a:xfrm>
           <a:prstGeom prst="rect">
             <a:avLst/>
@@ -4990,16 +4305,12 @@
           <a:noFill/>
         </p:spPr>
         <p:txBody>
-          <a:bodyPr wrap="square" anchor="ctr">
+          <a:bodyPr wrap="square">
             <a:spAutoFit/>
           </a:bodyPr>
           <a:lstStyle/>
           <a:p>
-            <a:pPr algn="r">
-              <a:spcAft>
-                <a:spcPts val="0"/>
-              </a:spcAft>
-            </a:pPr>
+            <a:pPr algn="r"/>
             <a:r>
               <a:rPr sz="900" b="0" i="0">
                 <a:solidFill>
@@ -5039,7 +4350,7 @@
         <p:spPr>
           <a:xfrm>
             <a:off x="0" y="0"/>
-            <a:ext cx="12191695" cy="960120"/>
+            <a:ext cx="12191695" cy="914400"/>
           </a:xfrm>
           <a:prstGeom prst="rect">
             <a:avLst/>
@@ -5050,7 +4361,6 @@
           <a:ln>
             <a:noFill/>
           </a:ln>
-          <a:effectLst/>
         </p:spPr>
         <p:style>
           <a:lnRef idx="1">
@@ -5083,7 +4393,7 @@
         <p:spPr>
           <a:xfrm>
             <a:off x="0" y="0"/>
-            <a:ext cx="164592" cy="960120"/>
+            <a:ext cx="137160" cy="914400"/>
           </a:xfrm>
           <a:prstGeom prst="rect">
             <a:avLst/>
@@ -5094,7 +4404,6 @@
           <a:ln>
             <a:noFill/>
           </a:ln>
-          <a:effectLst/>
         </p:spPr>
         <p:style>
           <a:lnRef idx="1">
@@ -5126,8 +4435,8 @@
         </p:nvSpPr>
         <p:spPr>
           <a:xfrm>
-            <a:off x="457200" y="109728"/>
-            <a:ext cx="10972800" cy="256032"/>
+            <a:off x="411480" y="91440"/>
+            <a:ext cx="10972800" cy="274320"/>
           </a:xfrm>
           <a:prstGeom prst="rect">
             <a:avLst/>
@@ -5135,16 +4444,12 @@
           <a:noFill/>
         </p:spPr>
         <p:txBody>
-          <a:bodyPr wrap="square" anchor="t">
+          <a:bodyPr wrap="square">
             <a:spAutoFit/>
           </a:bodyPr>
           <a:lstStyle/>
           <a:p>
-            <a:pPr algn="l">
-              <a:spcAft>
-                <a:spcPts val="0"/>
-              </a:spcAft>
-            </a:pPr>
+            <a:pPr algn="l"/>
             <a:r>
               <a:rPr sz="1100" b="1" i="0">
                 <a:solidFill>
@@ -5152,7 +4457,7 @@
                 </a:solidFill>
                 <a:latin typeface="Calibri"/>
               </a:rPr>
-              <a:t>PROGRAMME FIT</a:t>
+              <a:t>ALIGNMENT</a:t>
             </a:r>
           </a:p>
         </p:txBody>
@@ -5165,8 +4470,8 @@
         </p:nvSpPr>
         <p:spPr>
           <a:xfrm>
-            <a:off x="457200" y="384048"/>
-            <a:ext cx="11247120" cy="475488"/>
+            <a:off x="411480" y="384048"/>
+            <a:ext cx="10972800" cy="457200"/>
           </a:xfrm>
           <a:prstGeom prst="rect">
             <a:avLst/>
@@ -5174,24 +4479,20 @@
           <a:noFill/>
         </p:spPr>
         <p:txBody>
-          <a:bodyPr wrap="square" anchor="t">
+          <a:bodyPr wrap="square">
             <a:spAutoFit/>
           </a:bodyPr>
           <a:lstStyle/>
           <a:p>
-            <a:pPr algn="l">
-              <a:spcAft>
-                <a:spcPts val="0"/>
-              </a:spcAft>
-            </a:pPr>
-            <a:r>
-              <a:rPr sz="2200" b="1" i="0">
+            <a:pPr algn="l"/>
+            <a:r>
+              <a:rPr sz="2400" b="1" i="0">
                 <a:solidFill>
                   <a:srgbClr val="0A1F2E"/>
                 </a:solidFill>
                 <a:latin typeface="Calibri"/>
               </a:rPr>
-              <a:t>Why this call matches FCHIP</a:t>
+              <a:t>Energize Africa · Agenda 2063 Goal 18</a:t>
             </a:r>
           </a:p>
         </p:txBody>
@@ -5204,8 +4505,8 @@
         </p:nvSpPr>
         <p:spPr>
           <a:xfrm>
-            <a:off x="411480" y="1188720"/>
-            <a:ext cx="11338560" cy="1223010"/>
+            <a:off x="457200" y="1143000"/>
+            <a:ext cx="11155680" cy="914400"/>
           </a:xfrm>
           <a:prstGeom prst="rect">
             <a:avLst/>
@@ -5213,12 +4514,11 @@
           <a:solidFill>
             <a:srgbClr val="FFFFFF"/>
           </a:solidFill>
-          <a:ln w="9525">
+          <a:ln>
             <a:solidFill>
               <a:srgbClr val="D0DCDC"/>
             </a:solidFill>
           </a:ln>
-          <a:effectLst/>
         </p:spPr>
         <p:style>
           <a:lnRef idx="1">
@@ -5250,8 +4550,8 @@
         </p:nvSpPr>
         <p:spPr>
           <a:xfrm>
-            <a:off x="594360" y="1252728"/>
-            <a:ext cx="2926080" cy="1085850"/>
+            <a:off x="685800" y="1325880"/>
+            <a:ext cx="10515600" cy="548640"/>
           </a:xfrm>
           <a:prstGeom prst="rect">
             <a:avLst/>
@@ -5259,77 +4559,34 @@
           <a:noFill/>
         </p:spPr>
         <p:txBody>
-          <a:bodyPr wrap="square" anchor="ctr">
+          <a:bodyPr wrap="square">
             <a:spAutoFit/>
           </a:bodyPr>
           <a:lstStyle/>
           <a:p>
-            <a:pPr algn="l">
-              <a:spcAft>
-                <a:spcPts val="0"/>
-              </a:spcAft>
-            </a:pPr>
-            <a:r>
-              <a:rPr sz="1300" b="1" i="0">
+            <a:pPr algn="l"/>
+            <a:r>
+              <a:rPr sz="1500" b="0" i="0">
                 <a:solidFill>
-                  <a:srgbClr val="0D6E6E"/>
+                  <a:srgbClr val="1E2F38"/>
                 </a:solidFill>
                 <a:latin typeface="Calibri"/>
               </a:rPr>
-              <a:t>Ages 18–35, AU citizens</a:t>
-            </a:r>
-          </a:p>
-        </p:txBody>
-      </p:sp>
-      <p:sp>
-        <p:nvSpPr>
-          <p:cNvPr id="8" name="TextBox 7"/>
-          <p:cNvSpPr txBox="1"/>
-          <p:nvPr/>
-        </p:nvSpPr>
-        <p:spPr>
-          <a:xfrm>
-            <a:off x="3657600" y="1252728"/>
-            <a:ext cx="7772400" cy="1085850"/>
-          </a:xfrm>
-          <a:prstGeom prst="rect">
-            <a:avLst/>
-          </a:prstGeom>
-          <a:noFill/>
-        </p:spPr>
-        <p:txBody>
-          <a:bodyPr wrap="square" anchor="ctr">
-            <a:spAutoFit/>
-          </a:bodyPr>
-          <a:lstStyle/>
-          <a:p>
-            <a:pPr algn="l">
-              <a:spcAft>
-                <a:spcPts val="0"/>
-              </a:spcAft>
-            </a:pPr>
-            <a:r>
-              <a:rPr sz="1200" b="0" i="0">
-                <a:solidFill>
-                  <a:srgbClr val="3A4A54"/>
-                </a:solidFill>
-                <a:latin typeface="Calibri"/>
-              </a:rPr>
-              <a:t>Ugandan youth applicants in range</a:t>
-            </a:r>
-          </a:p>
-        </p:txBody>
-      </p:sp>
-      <p:sp>
-        <p:nvSpPr>
-          <p:cNvPr id="9" name="Rectangle 8"/>
+              <a:t>Youth as co-creators — not passive beneficiaries — in SRH programming</a:t>
+            </a:r>
+          </a:p>
+        </p:txBody>
+      </p:sp>
+      <p:sp>
+        <p:nvSpPr>
+          <p:cNvPr id="8" name="Rectangle 7"/>
           <p:cNvSpPr/>
           <p:nvPr/>
         </p:nvSpPr>
         <p:spPr>
           <a:xfrm>
-            <a:off x="411480" y="2503170"/>
-            <a:ext cx="11338560" cy="1223010"/>
+            <a:off x="457200" y="2194560"/>
+            <a:ext cx="11155680" cy="914400"/>
           </a:xfrm>
           <a:prstGeom prst="rect">
             <a:avLst/>
@@ -5337,12 +4594,11 @@
           <a:solidFill>
             <a:srgbClr val="FFFFFF"/>
           </a:solidFill>
-          <a:ln w="9525">
+          <a:ln>
             <a:solidFill>
               <a:srgbClr val="D0DCDC"/>
             </a:solidFill>
           </a:ln>
-          <a:effectLst/>
         </p:spPr>
         <p:style>
           <a:lnRef idx="1">
@@ -5368,14 +4624,14 @@
       </p:sp>
       <p:sp>
         <p:nvSpPr>
-          <p:cNvPr id="10" name="TextBox 9"/>
+          <p:cNvPr id="9" name="TextBox 8"/>
           <p:cNvSpPr txBox="1"/>
           <p:nvPr/>
         </p:nvSpPr>
         <p:spPr>
           <a:xfrm>
-            <a:off x="594360" y="2567178"/>
-            <a:ext cx="2926080" cy="1085850"/>
+            <a:off x="685800" y="2377440"/>
+            <a:ext cx="10515600" cy="548640"/>
           </a:xfrm>
           <a:prstGeom prst="rect">
             <a:avLst/>
@@ -5383,77 +4639,34 @@
           <a:noFill/>
         </p:spPr>
         <p:txBody>
-          <a:bodyPr wrap="square" anchor="ctr">
+          <a:bodyPr wrap="square">
             <a:spAutoFit/>
           </a:bodyPr>
           <a:lstStyle/>
           <a:p>
-            <a:pPr algn="l">
-              <a:spcAft>
-                <a:spcPts val="0"/>
-              </a:spcAft>
-            </a:pPr>
-            <a:r>
-              <a:rPr sz="1300" b="1" i="0">
+            <a:pPr algn="l"/>
+            <a:r>
+              <a:rPr sz="1500" b="0" i="0">
                 <a:solidFill>
-                  <a:srgbClr val="0D6E6E"/>
+                  <a:srgbClr val="1E2F38"/>
                 </a:solidFill>
                 <a:latin typeface="Calibri"/>
               </a:rPr>
-              <a:t>SRH commitment</a:t>
-            </a:r>
-          </a:p>
-        </p:txBody>
-      </p:sp>
-      <p:sp>
-        <p:nvSpPr>
-          <p:cNvPr id="11" name="TextBox 10"/>
-          <p:cNvSpPr txBox="1"/>
-          <p:nvPr/>
-        </p:nvSpPr>
-        <p:spPr>
-          <a:xfrm>
-            <a:off x="3657600" y="2567178"/>
-            <a:ext cx="7772400" cy="1085850"/>
-          </a:xfrm>
-          <a:prstGeom prst="rect">
-            <a:avLst/>
-          </a:prstGeom>
-          <a:noFill/>
-        </p:spPr>
-        <p:txBody>
-          <a:bodyPr wrap="square" anchor="ctr">
-            <a:spAutoFit/>
-          </a:bodyPr>
-          <a:lstStyle/>
-          <a:p>
-            <a:pPr algn="l">
-              <a:spcAft>
-                <a:spcPts val="0"/>
-              </a:spcAft>
-            </a:pPr>
-            <a:r>
-              <a:rPr sz="1200" b="0" i="0">
-                <a:solidFill>
-                  <a:srgbClr val="3A4A54"/>
-                </a:solidFill>
-                <a:latin typeface="Calibri"/>
-              </a:rPr>
-              <a:t>Active in maternal / adolescent community health work</a:t>
-            </a:r>
-          </a:p>
-        </p:txBody>
-      </p:sp>
-      <p:sp>
-        <p:nvSpPr>
-          <p:cNvPr id="12" name="Rectangle 11"/>
+              <a:t>Grassroots realities from Kampala communities informing continental advocacy</a:t>
+            </a:r>
+          </a:p>
+        </p:txBody>
+      </p:sp>
+      <p:sp>
+        <p:nvSpPr>
+          <p:cNvPr id="10" name="Rectangle 9"/>
           <p:cNvSpPr/>
           <p:nvPr/>
         </p:nvSpPr>
         <p:spPr>
           <a:xfrm>
-            <a:off x="411480" y="3817620"/>
-            <a:ext cx="11338560" cy="1223010"/>
+            <a:off x="457200" y="3246120"/>
+            <a:ext cx="11155680" cy="914400"/>
           </a:xfrm>
           <a:prstGeom prst="rect">
             <a:avLst/>
@@ -5461,12 +4674,11 @@
           <a:solidFill>
             <a:srgbClr val="FFFFFF"/>
           </a:solidFill>
-          <a:ln w="9525">
+          <a:ln>
             <a:solidFill>
               <a:srgbClr val="D0DCDC"/>
             </a:solidFill>
           </a:ln>
-          <a:effectLst/>
         </p:spPr>
         <p:style>
           <a:lnRef idx="1">
@@ -5492,14 +4704,14 @@
       </p:sp>
       <p:sp>
         <p:nvSpPr>
-          <p:cNvPr id="13" name="TextBox 12"/>
+          <p:cNvPr id="11" name="TextBox 10"/>
           <p:cNvSpPr txBox="1"/>
           <p:nvPr/>
         </p:nvSpPr>
         <p:spPr>
           <a:xfrm>
-            <a:off x="594360" y="3881628"/>
-            <a:ext cx="2926080" cy="1085850"/>
+            <a:off x="685800" y="3429000"/>
+            <a:ext cx="10515600" cy="548640"/>
           </a:xfrm>
           <a:prstGeom prst="rect">
             <a:avLst/>
@@ -5507,77 +4719,34 @@
           <a:noFill/>
         </p:spPr>
         <p:txBody>
-          <a:bodyPr wrap="square" anchor="ctr">
+          <a:bodyPr wrap="square">
             <a:spAutoFit/>
           </a:bodyPr>
           <a:lstStyle/>
           <a:p>
-            <a:pPr algn="l">
-              <a:spcAft>
-                <a:spcPts val="0"/>
-              </a:spcAft>
-            </a:pPr>
-            <a:r>
-              <a:rPr sz="1300" b="1" i="0">
+            <a:pPr algn="l"/>
+            <a:r>
+              <a:rPr sz="1500" b="0" i="0">
                 <a:solidFill>
-                  <a:srgbClr val="0D6E6E"/>
+                  <a:srgbClr val="1E2F38"/>
                 </a:solidFill>
                 <a:latin typeface="Calibri"/>
               </a:rPr>
-              <a:t>Digital presence</a:t>
-            </a:r>
-          </a:p>
-        </p:txBody>
-      </p:sp>
-      <p:sp>
-        <p:nvSpPr>
-          <p:cNvPr id="14" name="TextBox 13"/>
-          <p:cNvSpPr txBox="1"/>
-          <p:nvPr/>
-        </p:nvSpPr>
-        <p:spPr>
-          <a:xfrm>
-            <a:off x="3657600" y="3881628"/>
-            <a:ext cx="7772400" cy="1085850"/>
-          </a:xfrm>
-          <a:prstGeom prst="rect">
-            <a:avLst/>
-          </a:prstGeom>
-          <a:noFill/>
-        </p:spPr>
-        <p:txBody>
-          <a:bodyPr wrap="square" anchor="ctr">
-            <a:spAutoFit/>
-          </a:bodyPr>
-          <a:lstStyle/>
-          <a:p>
-            <a:pPr algn="l">
-              <a:spcAft>
-                <a:spcPts val="0"/>
-              </a:spcAft>
-            </a:pPr>
-            <a:r>
-              <a:rPr sz="1200" b="0" i="0">
-                <a:solidFill>
-                  <a:srgbClr val="3A4A54"/>
-                </a:solidFill>
-                <a:latin typeface="Calibri"/>
-              </a:rPr>
-              <a:t>Team can maintain responsible advocacy channels</a:t>
-            </a:r>
-          </a:p>
-        </p:txBody>
-      </p:sp>
-      <p:sp>
-        <p:nvSpPr>
-          <p:cNvPr id="15" name="Rectangle 14"/>
+              <a:t>Linking SRH to livelihoods, education, and the demographic dividend</a:t>
+            </a:r>
+          </a:p>
+        </p:txBody>
+      </p:sp>
+      <p:sp>
+        <p:nvSpPr>
+          <p:cNvPr id="12" name="Rectangle 11"/>
           <p:cNvSpPr/>
           <p:nvPr/>
         </p:nvSpPr>
         <p:spPr>
           <a:xfrm>
-            <a:off x="411480" y="5132070"/>
-            <a:ext cx="11338560" cy="1223010"/>
+            <a:off x="457200" y="4297680"/>
+            <a:ext cx="11155680" cy="914400"/>
           </a:xfrm>
           <a:prstGeom prst="rect">
             <a:avLst/>
@@ -5585,12 +4754,11 @@
           <a:solidFill>
             <a:srgbClr val="FFFFFF"/>
           </a:solidFill>
-          <a:ln w="9525">
+          <a:ln>
             <a:solidFill>
               <a:srgbClr val="D0DCDC"/>
             </a:solidFill>
           </a:ln>
-          <a:effectLst/>
         </p:spPr>
         <p:style>
           <a:lnRef idx="1">
@@ -5616,14 +4784,14 @@
       </p:sp>
       <p:sp>
         <p:nvSpPr>
-          <p:cNvPr id="16" name="TextBox 15"/>
+          <p:cNvPr id="13" name="TextBox 12"/>
           <p:cNvSpPr txBox="1"/>
           <p:nvPr/>
         </p:nvSpPr>
         <p:spPr>
           <a:xfrm>
-            <a:off x="594360" y="5196078"/>
-            <a:ext cx="2926080" cy="1085850"/>
+            <a:off x="685800" y="4480560"/>
+            <a:ext cx="10515600" cy="548640"/>
           </a:xfrm>
           <a:prstGeom prst="rect">
             <a:avLst/>
@@ -5631,77 +4799,34 @@
           <a:noFill/>
         </p:spPr>
         <p:txBody>
-          <a:bodyPr wrap="square" anchor="ctr">
+          <a:bodyPr wrap="square">
             <a:spAutoFit/>
           </a:bodyPr>
           <a:lstStyle/>
           <a:p>
-            <a:pPr algn="l">
-              <a:spcAft>
-                <a:spcPts val="0"/>
-              </a:spcAft>
-            </a:pPr>
-            <a:r>
-              <a:rPr sz="1300" b="1" i="0">
+            <a:pPr algn="l"/>
+            <a:r>
+              <a:rPr sz="1500" b="0" i="0">
                 <a:solidFill>
-                  <a:srgbClr val="0D6E6E"/>
+                  <a:srgbClr val="1E2F38"/>
                 </a:solidFill>
                 <a:latin typeface="Calibri"/>
               </a:rPr>
-              <a:t>Voluntary service</a:t>
-            </a:r>
-          </a:p>
-        </p:txBody>
-      </p:sp>
-      <p:sp>
-        <p:nvSpPr>
-          <p:cNvPr id="17" name="TextBox 16"/>
-          <p:cNvSpPr txBox="1"/>
-          <p:nvPr/>
-        </p:nvSpPr>
-        <p:spPr>
-          <a:xfrm>
-            <a:off x="3657600" y="5196078"/>
-            <a:ext cx="7772400" cy="1085850"/>
-          </a:xfrm>
-          <a:prstGeom prst="rect">
-            <a:avLst/>
-          </a:prstGeom>
-          <a:noFill/>
-        </p:spPr>
-        <p:txBody>
-          <a:bodyPr wrap="square" anchor="ctr">
-            <a:spAutoFit/>
-          </a:bodyPr>
-          <a:lstStyle/>
-          <a:p>
-            <a:pPr algn="l">
-              <a:spcAft>
-                <a:spcPts val="0"/>
-              </a:spcAft>
-            </a:pPr>
-            <a:r>
-              <a:rPr sz="1200" b="0" i="0">
-                <a:solidFill>
-                  <a:srgbClr val="3A4A54"/>
-                </a:solidFill>
-                <a:latin typeface="Calibri"/>
-              </a:rPr>
-              <a:t>Clear understanding: recognition and training, not a salary</a:t>
-            </a:r>
-          </a:p>
-        </p:txBody>
-      </p:sp>
-      <p:sp>
-        <p:nvSpPr>
-          <p:cNvPr id="18" name="Rectangle 17"/>
+              <a:t>Amplifying AUDA-NEPAD frameworks through lived FairBanks field experience</a:t>
+            </a:r>
+          </a:p>
+        </p:txBody>
+      </p:sp>
+      <p:sp>
+        <p:nvSpPr>
+          <p:cNvPr id="14" name="Rectangle 13"/>
           <p:cNvSpPr/>
           <p:nvPr/>
         </p:nvSpPr>
         <p:spPr>
           <a:xfrm>
-            <a:off x="0" y="6565392"/>
-            <a:ext cx="12191695" cy="292608"/>
+            <a:off x="0" y="6583680"/>
+            <a:ext cx="12191695" cy="274320"/>
           </a:xfrm>
           <a:prstGeom prst="rect">
             <a:avLst/>
@@ -5712,7 +4837,6 @@
           <a:ln>
             <a:noFill/>
           </a:ln>
-          <a:effectLst/>
         </p:spPr>
         <p:style>
           <a:lnRef idx="1">
@@ -5738,14 +4862,14 @@
       </p:sp>
       <p:sp>
         <p:nvSpPr>
-          <p:cNvPr id="19" name="TextBox 18"/>
+          <p:cNvPr id="15" name="TextBox 14"/>
           <p:cNvSpPr txBox="1"/>
           <p:nvPr/>
         </p:nvSpPr>
         <p:spPr>
           <a:xfrm>
-            <a:off x="365760" y="6574536"/>
-            <a:ext cx="9144000" cy="274320"/>
+            <a:off x="365760" y="6592824"/>
+            <a:ext cx="9144000" cy="256032"/>
           </a:xfrm>
           <a:prstGeom prst="rect">
             <a:avLst/>
@@ -5753,16 +4877,12 @@
           <a:noFill/>
         </p:spPr>
         <p:txBody>
-          <a:bodyPr wrap="square" anchor="ctr">
+          <a:bodyPr wrap="square">
             <a:spAutoFit/>
           </a:bodyPr>
           <a:lstStyle/>
           <a:p>
-            <a:pPr algn="l">
-              <a:spcAft>
-                <a:spcPts val="0"/>
-              </a:spcAft>
-            </a:pPr>
+            <a:pPr algn="l"/>
             <a:r>
               <a:rPr sz="900" b="0" i="0">
                 <a:solidFill>
@@ -5770,21 +4890,21 @@
                 </a:solidFill>
                 <a:latin typeface="Calibri"/>
               </a:rPr>
-              <a:t>FairBanks FCHIP  |  AUDA-NEPAD Youth SRH Ambassadors Initiat  |  Your health, our mission.</a:t>
-            </a:r>
-          </a:p>
-        </p:txBody>
-      </p:sp>
-      <p:sp>
-        <p:nvSpPr>
-          <p:cNvPr id="20" name="TextBox 19"/>
+              <a:t>FairBanks | AUDA-NEPAD Youth SRH Ambassador | Your health, our mission.</a:t>
+            </a:r>
+          </a:p>
+        </p:txBody>
+      </p:sp>
+      <p:sp>
+        <p:nvSpPr>
+          <p:cNvPr id="16" name="TextBox 15"/>
           <p:cNvSpPr txBox="1"/>
           <p:nvPr/>
         </p:nvSpPr>
         <p:spPr>
           <a:xfrm>
-            <a:off x="11094415" y="6574536"/>
-            <a:ext cx="731520" cy="274320"/>
+            <a:off x="11460175" y="6592824"/>
+            <a:ext cx="457200" cy="256032"/>
           </a:xfrm>
           <a:prstGeom prst="rect">
             <a:avLst/>
@@ -5792,16 +4912,12 @@
           <a:noFill/>
         </p:spPr>
         <p:txBody>
-          <a:bodyPr wrap="square" anchor="ctr">
+          <a:bodyPr wrap="square">
             <a:spAutoFit/>
           </a:bodyPr>
           <a:lstStyle/>
           <a:p>
-            <a:pPr algn="r">
-              <a:spcAft>
-                <a:spcPts val="0"/>
-              </a:spcAft>
-            </a:pPr>
+            <a:pPr algn="r"/>
             <a:r>
               <a:rPr sz="900" b="0" i="0">
                 <a:solidFill>
@@ -5841,7 +4957,7 @@
         <p:spPr>
           <a:xfrm>
             <a:off x="0" y="0"/>
-            <a:ext cx="12191695" cy="960120"/>
+            <a:ext cx="12191695" cy="914400"/>
           </a:xfrm>
           <a:prstGeom prst="rect">
             <a:avLst/>
@@ -5852,7 +4968,6 @@
           <a:ln>
             <a:noFill/>
           </a:ln>
-          <a:effectLst/>
         </p:spPr>
         <p:style>
           <a:lnRef idx="1">
@@ -5885,7 +5000,7 @@
         <p:spPr>
           <a:xfrm>
             <a:off x="0" y="0"/>
-            <a:ext cx="164592" cy="960120"/>
+            <a:ext cx="137160" cy="914400"/>
           </a:xfrm>
           <a:prstGeom prst="rect">
             <a:avLst/>
@@ -5896,7 +5011,6 @@
           <a:ln>
             <a:noFill/>
           </a:ln>
-          <a:effectLst/>
         </p:spPr>
         <p:style>
           <a:lnRef idx="1">
@@ -5928,8 +5042,8 @@
         </p:nvSpPr>
         <p:spPr>
           <a:xfrm>
-            <a:off x="457200" y="109728"/>
-            <a:ext cx="10972800" cy="256032"/>
+            <a:off x="411480" y="91440"/>
+            <a:ext cx="10972800" cy="274320"/>
           </a:xfrm>
           <a:prstGeom prst="rect">
             <a:avLst/>
@@ -5937,16 +5051,12 @@
           <a:noFill/>
         </p:spPr>
         <p:txBody>
-          <a:bodyPr wrap="square" anchor="t">
+          <a:bodyPr wrap="square">
             <a:spAutoFit/>
           </a:bodyPr>
           <a:lstStyle/>
           <a:p>
-            <a:pPr algn="l">
-              <a:spcAft>
-                <a:spcPts val="0"/>
-              </a:spcAft>
-            </a:pPr>
+            <a:pPr algn="l"/>
             <a:r>
               <a:rPr sz="1100" b="1" i="0">
                 <a:solidFill>
@@ -5954,7 +5064,7 @@
                 </a:solidFill>
                 <a:latin typeface="Calibri"/>
               </a:rPr>
-              <a:t>WHY FAIRBANKS</a:t>
+              <a:t>IF SELECTED</a:t>
             </a:r>
           </a:p>
         </p:txBody>
@@ -5967,8 +5077,8 @@
         </p:nvSpPr>
         <p:spPr>
           <a:xfrm>
-            <a:off x="457200" y="384048"/>
-            <a:ext cx="11247120" cy="475488"/>
+            <a:off x="411480" y="384048"/>
+            <a:ext cx="10972800" cy="457200"/>
           </a:xfrm>
           <a:prstGeom prst="rect">
             <a:avLst/>
@@ -5976,31 +5086,27 @@
           <a:noFill/>
         </p:spPr>
         <p:txBody>
-          <a:bodyPr wrap="square" anchor="t">
+          <a:bodyPr wrap="square">
             <a:spAutoFit/>
           </a:bodyPr>
           <a:lstStyle/>
           <a:p>
-            <a:pPr algn="l">
-              <a:spcAft>
-                <a:spcPts val="0"/>
-              </a:spcAft>
-            </a:pPr>
-            <a:r>
-              <a:rPr sz="2200" b="1" i="0">
+            <a:pPr algn="l"/>
+            <a:r>
+              <a:rPr sz="2400" b="1" i="0">
                 <a:solidFill>
                   <a:srgbClr val="0A1F2E"/>
                 </a:solidFill>
                 <a:latin typeface="Calibri"/>
               </a:rPr>
-              <a:t>A live community health ecosystem</a:t>
+              <a:t>Ambassador commitments</a:t>
             </a:r>
           </a:p>
         </p:txBody>
       </p:sp>
       <p:pic>
         <p:nvPicPr>
-          <p:cNvPr id="6" name="Picture 5" descr="outreach_facilitator_canopy_01_opt.jpg"/>
+          <p:cNvPr id="6" name="Picture 5" descr="outreach_mobile_phone_demo_01_opt.jpg"/>
           <p:cNvPicPr>
             <a:picLocks noChangeAspect="1"/>
           </p:cNvPicPr>
@@ -6014,8 +5120,8 @@
         </p:blipFill>
         <p:spPr>
           <a:xfrm>
-            <a:off x="411480" y="1943753"/>
-            <a:ext cx="5486400" cy="3656293"/>
+            <a:off x="411480" y="2026920"/>
+            <a:ext cx="4754880" cy="3169920"/>
           </a:xfrm>
           <a:prstGeom prst="rect">
             <a:avLst/>
@@ -6030,8 +5136,8 @@
         </p:nvSpPr>
         <p:spPr>
           <a:xfrm>
-            <a:off x="6217920" y="1234440"/>
-            <a:ext cx="5486400" cy="5074920"/>
+            <a:off x="5486400" y="1097280"/>
+            <a:ext cx="6217920" cy="5029200"/>
           </a:xfrm>
           <a:prstGeom prst="rect">
             <a:avLst/>
@@ -6044,99 +5150,18 @@
           </a:bodyPr>
           <a:lstStyle/>
           <a:p>
-            <a:pPr>
-              <a:spcAft>
-                <a:spcPts val="800"/>
-              </a:spcAft>
-            </a:pPr>
-            <a:r>
-              <a:rPr sz="1400">
+            <a:pPr algn="l"/>
+            <a:r>
+              <a:rPr sz="1400" b="0" i="0">
                 <a:solidFill>
                   <a:srgbClr val="1E2F38"/>
                 </a:solidFill>
                 <a:latin typeface="Calibri"/>
               </a:rPr>
-              <a:t>•  Functioning FairBanks Medical Centre with clinic, pharmacy, and diagnostics</a:t>
-            </a:r>
-          </a:p>
-          <a:p>
-            <a:pPr>
-              <a:spcAft>
-                <a:spcPts val="800"/>
-              </a:spcAft>
-            </a:pPr>
-            <a:r>
-              <a:rPr sz="1400">
-                <a:solidFill>
-                  <a:srgbClr val="1E2F38"/>
-                </a:solidFill>
-                <a:latin typeface="Calibri"/>
-              </a:rPr>
-              <a:t>•  Active Community Reach outreach in Bukoto, Kyebando, Kisaasi, Kamwokya, Kikaaya</a:t>
-            </a:r>
-          </a:p>
-          <a:p>
-            <a:pPr>
-              <a:spcAft>
-                <a:spcPts val="800"/>
-              </a:spcAft>
-            </a:pPr>
-            <a:r>
-              <a:rPr sz="1400">
-                <a:solidFill>
-                  <a:srgbClr val="1E2F38"/>
-                </a:solidFill>
-                <a:latin typeface="Calibri"/>
-              </a:rPr>
-              <a:t>•  Trusted CHW and VHT relationships for household visits and referrals</a:t>
-            </a:r>
-          </a:p>
-          <a:p>
-            <a:pPr>
-              <a:spcAft>
-                <a:spcPts val="800"/>
-              </a:spcAft>
-            </a:pPr>
-            <a:r>
-              <a:rPr sz="1400">
-                <a:solidFill>
-                  <a:srgbClr val="1E2F38"/>
-                </a:solidFill>
-                <a:latin typeface="Calibri"/>
-              </a:rPr>
-              <a:t>•  Live programmes: maternal &amp; child health, Gericare, chronic-disease screening</a:t>
-            </a:r>
-          </a:p>
-          <a:p>
-            <a:pPr>
-              <a:spcAft>
-                <a:spcPts val="800"/>
-              </a:spcAft>
-            </a:pPr>
-            <a:r>
-              <a:rPr sz="1400">
-                <a:solidFill>
-                  <a:srgbClr val="1E2F38"/>
-                </a:solidFill>
-                <a:latin typeface="Calibri"/>
-              </a:rPr>
-              <a:t>•  Digital health records and outreach data ready to feed FCHIP</a:t>
-            </a:r>
-          </a:p>
-          <a:p>
-            <a:pPr>
-              <a:spcAft>
-                <a:spcPts val="800"/>
-              </a:spcAft>
-            </a:pPr>
-            <a:r>
-              <a:rPr sz="1400">
-                <a:solidFill>
-                  <a:srgbClr val="1E2F38"/>
-                </a:solidFill>
-                <a:latin typeface="Calibri"/>
-              </a:rPr>
-              <a:t>•  Research and partnership mindset for ethical, evidence-based scale</a:t>
+              <a:t>• Monthly advocacy content tied to outreach calendars and adolescent/maternal programmes
+• Report anonymised community insights upward — what youth actually ask in the field
+• Support A2DSRH and Energize Africa messaging with honest, local-language examples
+• Mentor younger peer advocates through FairBanks Community Reach volunteer pathways</a:t>
             </a:r>
           </a:p>
         </p:txBody>
@@ -6149,8 +5174,8 @@
         </p:nvSpPr>
         <p:spPr>
           <a:xfrm>
-            <a:off x="0" y="6565392"/>
-            <a:ext cx="12191695" cy="292608"/>
+            <a:off x="0" y="6583680"/>
+            <a:ext cx="12191695" cy="274320"/>
           </a:xfrm>
           <a:prstGeom prst="rect">
             <a:avLst/>
@@ -6161,7 +5186,6 @@
           <a:ln>
             <a:noFill/>
           </a:ln>
-          <a:effectLst/>
         </p:spPr>
         <p:style>
           <a:lnRef idx="1">
@@ -6193,8 +5217,8 @@
         </p:nvSpPr>
         <p:spPr>
           <a:xfrm>
-            <a:off x="365760" y="6574536"/>
-            <a:ext cx="9144000" cy="274320"/>
+            <a:off x="365760" y="6592824"/>
+            <a:ext cx="9144000" cy="256032"/>
           </a:xfrm>
           <a:prstGeom prst="rect">
             <a:avLst/>
@@ -6202,16 +5226,12 @@
           <a:noFill/>
         </p:spPr>
         <p:txBody>
-          <a:bodyPr wrap="square" anchor="ctr">
+          <a:bodyPr wrap="square">
             <a:spAutoFit/>
           </a:bodyPr>
           <a:lstStyle/>
           <a:p>
-            <a:pPr algn="l">
-              <a:spcAft>
-                <a:spcPts val="0"/>
-              </a:spcAft>
-            </a:pPr>
+            <a:pPr algn="l"/>
             <a:r>
               <a:rPr sz="900" b="0" i="0">
                 <a:solidFill>
@@ -6219,7 +5239,7 @@
                 </a:solidFill>
                 <a:latin typeface="Calibri"/>
               </a:rPr>
-              <a:t>FairBanks FCHIP  |  AUDA-NEPAD Youth SRH Ambassadors Initiat  |  Your health, our mission.</a:t>
+              <a:t>FairBanks | AUDA-NEPAD Youth SRH Ambassador | Your health, our mission.</a:t>
             </a:r>
           </a:p>
         </p:txBody>
@@ -6232,8 +5252,8 @@
         </p:nvSpPr>
         <p:spPr>
           <a:xfrm>
-            <a:off x="11094415" y="6574536"/>
-            <a:ext cx="731520" cy="274320"/>
+            <a:off x="11460175" y="6592824"/>
+            <a:ext cx="457200" cy="256032"/>
           </a:xfrm>
           <a:prstGeom prst="rect">
             <a:avLst/>
@@ -6241,16 +5261,12 @@
           <a:noFill/>
         </p:spPr>
         <p:txBody>
-          <a:bodyPr wrap="square" anchor="ctr">
+          <a:bodyPr wrap="square">
             <a:spAutoFit/>
           </a:bodyPr>
           <a:lstStyle/>
           <a:p>
-            <a:pPr algn="r">
-              <a:spcAft>
-                <a:spcPts val="0"/>
-              </a:spcAft>
-            </a:pPr>
+            <a:pPr algn="r"/>
             <a:r>
               <a:rPr sz="900" b="0" i="0">
                 <a:solidFill>
@@ -6290,7 +5306,7 @@
         <p:spPr>
           <a:xfrm>
             <a:off x="0" y="0"/>
-            <a:ext cx="12191695" cy="960120"/>
+            <a:ext cx="12191695" cy="914400"/>
           </a:xfrm>
           <a:prstGeom prst="rect">
             <a:avLst/>
@@ -6301,7 +5317,6 @@
           <a:ln>
             <a:noFill/>
           </a:ln>
-          <a:effectLst/>
         </p:spPr>
         <p:style>
           <a:lnRef idx="1">
@@ -6334,7 +5349,7 @@
         <p:spPr>
           <a:xfrm>
             <a:off x="0" y="0"/>
-            <a:ext cx="164592" cy="960120"/>
+            <a:ext cx="137160" cy="914400"/>
           </a:xfrm>
           <a:prstGeom prst="rect">
             <a:avLst/>
@@ -6345,7 +5360,6 @@
           <a:ln>
             <a:noFill/>
           </a:ln>
-          <a:effectLst/>
         </p:spPr>
         <p:style>
           <a:lnRef idx="1">
@@ -6377,8 +5391,8 @@
         </p:nvSpPr>
         <p:spPr>
           <a:xfrm>
-            <a:off x="457200" y="109728"/>
-            <a:ext cx="10972800" cy="256032"/>
+            <a:off x="411480" y="91440"/>
+            <a:ext cx="10972800" cy="274320"/>
           </a:xfrm>
           <a:prstGeom prst="rect">
             <a:avLst/>
@@ -6386,16 +5400,12 @@
           <a:noFill/>
         </p:spPr>
         <p:txBody>
-          <a:bodyPr wrap="square" anchor="t">
+          <a:bodyPr wrap="square">
             <a:spAutoFit/>
           </a:bodyPr>
           <a:lstStyle/>
           <a:p>
-            <a:pPr algn="l">
-              <a:spcAft>
-                <a:spcPts val="0"/>
-              </a:spcAft>
-            </a:pPr>
+            <a:pPr algn="l"/>
             <a:r>
               <a:rPr sz="1100" b="1" i="0">
                 <a:solidFill>
@@ -6403,7 +5413,7 @@
                 </a:solidFill>
                 <a:latin typeface="Calibri"/>
               </a:rPr>
-              <a:t>THE PLAN</a:t>
+              <a:t>AMPLIFICATION</a:t>
             </a:r>
           </a:p>
         </p:txBody>
@@ -6416,8 +5426,8 @@
         </p:nvSpPr>
         <p:spPr>
           <a:xfrm>
-            <a:off x="457200" y="384048"/>
-            <a:ext cx="11247120" cy="475488"/>
+            <a:off x="411480" y="384048"/>
+            <a:ext cx="10972800" cy="457200"/>
           </a:xfrm>
           <a:prstGeom prst="rect">
             <a:avLst/>
@@ -6425,24 +5435,20 @@
           <a:noFill/>
         </p:spPr>
         <p:txBody>
-          <a:bodyPr wrap="square" anchor="t">
+          <a:bodyPr wrap="square">
             <a:spAutoFit/>
           </a:bodyPr>
           <a:lstStyle/>
           <a:p>
-            <a:pPr algn="l">
-              <a:spcAft>
-                <a:spcPts val="0"/>
-              </a:spcAft>
-            </a:pPr>
-            <a:r>
-              <a:rPr sz="2200" b="1" i="0">
+            <a:pPr algn="l"/>
+            <a:r>
+              <a:rPr sz="2400" b="1" i="0">
                 <a:solidFill>
                   <a:srgbClr val="0A1F2E"/>
                 </a:solidFill>
                 <a:latin typeface="Calibri"/>
               </a:rPr>
-              <a:t>Ambassador activity plan</a:t>
+              <a:t>What the ambassador platform adds</a:t>
             </a:r>
           </a:p>
         </p:txBody>
@@ -6455,8 +5461,8 @@
         </p:nvSpPr>
         <p:spPr>
           <a:xfrm>
-            <a:off x="502920" y="1234440"/>
-            <a:ext cx="5760720" cy="5074920"/>
+            <a:off x="457200" y="1097280"/>
+            <a:ext cx="5303520" cy="5029200"/>
           </a:xfrm>
           <a:prstGeom prst="rect">
             <a:avLst/>
@@ -6469,74 +5475,25 @@
           </a:bodyPr>
           <a:lstStyle/>
           <a:p>
-            <a:pPr>
-              <a:spcAft>
-                <a:spcPts val="800"/>
-              </a:spcAft>
-            </a:pPr>
-            <a:r>
-              <a:rPr sz="1500">
+            <a:pPr algn="l"/>
+            <a:r>
+              <a:rPr sz="1600" b="0" i="0">
                 <a:solidFill>
                   <a:srgbClr val="1E2F38"/>
                 </a:solidFill>
                 <a:latin typeface="Calibri"/>
               </a:rPr>
-              <a:t>•  Complete ambassador onboarding and training requirements</a:t>
-            </a:r>
-          </a:p>
-          <a:p>
-            <a:pPr>
-              <a:spcAft>
-                <a:spcPts val="800"/>
-              </a:spcAft>
-            </a:pPr>
-            <a:r>
-              <a:rPr sz="1500">
-                <a:solidFill>
-                  <a:srgbClr val="1E2F38"/>
-                </a:solidFill>
-                <a:latin typeface="Calibri"/>
-              </a:rPr>
-              <a:t>•  Run quarterly SRH awareness moments inside FairBanks outreach calendars</a:t>
-            </a:r>
-          </a:p>
-          <a:p>
-            <a:pPr>
-              <a:spcAft>
-                <a:spcPts val="800"/>
-              </a:spcAft>
-            </a:pPr>
-            <a:r>
-              <a:rPr sz="1500">
-                <a:solidFill>
-                  <a:srgbClr val="1E2F38"/>
-                </a:solidFill>
-                <a:latin typeface="Calibri"/>
-              </a:rPr>
-              <a:t>•  Report activity and learning back to AUDA-NEPAD as required</a:t>
-            </a:r>
-          </a:p>
-          <a:p>
-            <a:pPr>
-              <a:spcAft>
-                <a:spcPts val="800"/>
-              </a:spcAft>
-            </a:pPr>
-            <a:r>
-              <a:rPr sz="1500">
-                <a:solidFill>
-                  <a:srgbClr val="1E2F38"/>
-                </a:solidFill>
-                <a:latin typeface="Calibri"/>
-              </a:rPr>
-              <a:t>•  Protect privacy and avoid sharing identifiable patient data in advocacy</a:t>
+              <a:t>• Official ambassador recognition and continental SRH platforms
+• Training, mentorship, and networking with policy and youth leaders
+• Visibility to translate Kampala outreach lessons into Africa-wide dialogue
+• Sponsored participation in selected AUDA-NEPAD engagements where appropriate</a:t>
             </a:r>
           </a:p>
         </p:txBody>
       </p:sp>
       <p:pic>
         <p:nvPicPr>
-          <p:cNvPr id="7" name="Picture 6" descr="indoor_training_staff_presenting_01_opt.jpg"/>
+          <p:cNvPr id="7" name="Picture 6" descr="outreach_audience_full_group_01_opt.jpg"/>
           <p:cNvPicPr>
             <a:picLocks noChangeAspect="1"/>
           </p:cNvPicPr>
@@ -6550,8 +5507,8 @@
         </p:blipFill>
         <p:spPr>
           <a:xfrm>
-            <a:off x="6492240" y="2035160"/>
-            <a:ext cx="5212080" cy="3473479"/>
+            <a:off x="6035040" y="1722795"/>
+            <a:ext cx="5669280" cy="3778170"/>
           </a:xfrm>
           <a:prstGeom prst="rect">
             <a:avLst/>
@@ -6566,8 +5523,8 @@
         </p:nvSpPr>
         <p:spPr>
           <a:xfrm>
-            <a:off x="0" y="6565392"/>
-            <a:ext cx="12191695" cy="292608"/>
+            <a:off x="0" y="6583680"/>
+            <a:ext cx="12191695" cy="274320"/>
           </a:xfrm>
           <a:prstGeom prst="rect">
             <a:avLst/>
@@ -6578,7 +5535,6 @@
           <a:ln>
             <a:noFill/>
           </a:ln>
-          <a:effectLst/>
         </p:spPr>
         <p:style>
           <a:lnRef idx="1">
@@ -6610,8 +5566,8 @@
         </p:nvSpPr>
         <p:spPr>
           <a:xfrm>
-            <a:off x="365760" y="6574536"/>
-            <a:ext cx="9144000" cy="274320"/>
+            <a:off x="365760" y="6592824"/>
+            <a:ext cx="9144000" cy="256032"/>
           </a:xfrm>
           <a:prstGeom prst="rect">
             <a:avLst/>
@@ -6619,16 +5575,12 @@
           <a:noFill/>
         </p:spPr>
         <p:txBody>
-          <a:bodyPr wrap="square" anchor="ctr">
+          <a:bodyPr wrap="square">
             <a:spAutoFit/>
           </a:bodyPr>
           <a:lstStyle/>
           <a:p>
-            <a:pPr algn="l">
-              <a:spcAft>
-                <a:spcPts val="0"/>
-              </a:spcAft>
-            </a:pPr>
+            <a:pPr algn="l"/>
             <a:r>
               <a:rPr sz="900" b="0" i="0">
                 <a:solidFill>
@@ -6636,7 +5588,7 @@
                 </a:solidFill>
                 <a:latin typeface="Calibri"/>
               </a:rPr>
-              <a:t>FairBanks FCHIP  |  AUDA-NEPAD Youth SRH Ambassadors Initiat  |  Your health, our mission.</a:t>
+              <a:t>FairBanks | AUDA-NEPAD Youth SRH Ambassador | Your health, our mission.</a:t>
             </a:r>
           </a:p>
         </p:txBody>
@@ -6649,8 +5601,8 @@
         </p:nvSpPr>
         <p:spPr>
           <a:xfrm>
-            <a:off x="11094415" y="6574536"/>
-            <a:ext cx="731520" cy="274320"/>
+            <a:off x="11460175" y="6592824"/>
+            <a:ext cx="457200" cy="256032"/>
           </a:xfrm>
           <a:prstGeom prst="rect">
             <a:avLst/>
@@ -6658,16 +5610,12 @@
           <a:noFill/>
         </p:spPr>
         <p:txBody>
-          <a:bodyPr wrap="square" anchor="ctr">
+          <a:bodyPr wrap="square">
             <a:spAutoFit/>
           </a:bodyPr>
           <a:lstStyle/>
           <a:p>
-            <a:pPr algn="r">
-              <a:spcAft>
-                <a:spcPts val="0"/>
-              </a:spcAft>
-            </a:pPr>
+            <a:pPr algn="r"/>
             <a:r>
               <a:rPr sz="900" b="0" i="0">
                 <a:solidFill>
@@ -6698,175 +5646,9 @@
         <p:nvPr/>
       </p:nvGrpSpPr>
       <p:grpSpPr/>
-      <p:sp>
-        <p:nvSpPr>
-          <p:cNvPr id="2" name="Rectangle 1"/>
-          <p:cNvSpPr/>
-          <p:nvPr/>
-        </p:nvSpPr>
-        <p:spPr>
-          <a:xfrm>
-            <a:off x="0" y="0"/>
-            <a:ext cx="12191695" cy="960120"/>
-          </a:xfrm>
-          <a:prstGeom prst="rect">
-            <a:avLst/>
-          </a:prstGeom>
-          <a:solidFill>
-            <a:srgbClr val="F7F5F0"/>
-          </a:solidFill>
-          <a:ln>
-            <a:noFill/>
-          </a:ln>
-          <a:effectLst/>
-        </p:spPr>
-        <p:style>
-          <a:lnRef idx="1">
-            <a:schemeClr val="accent1"/>
-          </a:lnRef>
-          <a:fillRef idx="3">
-            <a:schemeClr val="accent1"/>
-          </a:fillRef>
-          <a:effectRef idx="2">
-            <a:schemeClr val="accent1"/>
-          </a:effectRef>
-          <a:fontRef idx="minor">
-            <a:schemeClr val="lt1"/>
-          </a:fontRef>
-        </p:style>
-        <p:txBody>
-          <a:bodyPr rtlCol="0" anchor="ctr"/>
-          <a:lstStyle/>
-          <a:p>
-            <a:pPr algn="ctr"/>
-          </a:p>
-        </p:txBody>
-      </p:sp>
-      <p:sp>
-        <p:nvSpPr>
-          <p:cNvPr id="3" name="Rectangle 2"/>
-          <p:cNvSpPr/>
-          <p:nvPr/>
-        </p:nvSpPr>
-        <p:spPr>
-          <a:xfrm>
-            <a:off x="0" y="0"/>
-            <a:ext cx="164592" cy="960120"/>
-          </a:xfrm>
-          <a:prstGeom prst="rect">
-            <a:avLst/>
-          </a:prstGeom>
-          <a:solidFill>
-            <a:srgbClr val="0D6E6E"/>
-          </a:solidFill>
-          <a:ln>
-            <a:noFill/>
-          </a:ln>
-          <a:effectLst/>
-        </p:spPr>
-        <p:style>
-          <a:lnRef idx="1">
-            <a:schemeClr val="accent1"/>
-          </a:lnRef>
-          <a:fillRef idx="3">
-            <a:schemeClr val="accent1"/>
-          </a:fillRef>
-          <a:effectRef idx="2">
-            <a:schemeClr val="accent1"/>
-          </a:effectRef>
-          <a:fontRef idx="minor">
-            <a:schemeClr val="lt1"/>
-          </a:fontRef>
-        </p:style>
-        <p:txBody>
-          <a:bodyPr rtlCol="0" anchor="ctr"/>
-          <a:lstStyle/>
-          <a:p>
-            <a:pPr algn="ctr"/>
-          </a:p>
-        </p:txBody>
-      </p:sp>
-      <p:sp>
-        <p:nvSpPr>
-          <p:cNvPr id="4" name="TextBox 3"/>
-          <p:cNvSpPr txBox="1"/>
-          <p:nvPr/>
-        </p:nvSpPr>
-        <p:spPr>
-          <a:xfrm>
-            <a:off x="457200" y="109728"/>
-            <a:ext cx="10972800" cy="256032"/>
-          </a:xfrm>
-          <a:prstGeom prst="rect">
-            <a:avLst/>
-          </a:prstGeom>
-          <a:noFill/>
-        </p:spPr>
-        <p:txBody>
-          <a:bodyPr wrap="square" anchor="t">
-            <a:spAutoFit/>
-          </a:bodyPr>
-          <a:lstStyle/>
-          <a:p>
-            <a:pPr algn="l">
-              <a:spcAft>
-                <a:spcPts val="0"/>
-              </a:spcAft>
-            </a:pPr>
-            <a:r>
-              <a:rPr sz="1100" b="1" i="0">
-                <a:solidFill>
-                  <a:srgbClr val="C45C26"/>
-                </a:solidFill>
-                <a:latin typeface="Calibri"/>
-              </a:rPr>
-              <a:t>DEEP TECHNOLOGY</a:t>
-            </a:r>
-          </a:p>
-        </p:txBody>
-      </p:sp>
-      <p:sp>
-        <p:nvSpPr>
-          <p:cNvPr id="5" name="TextBox 4"/>
-          <p:cNvSpPr txBox="1"/>
-          <p:nvPr/>
-        </p:nvSpPr>
-        <p:spPr>
-          <a:xfrm>
-            <a:off x="457200" y="384048"/>
-            <a:ext cx="11247120" cy="475488"/>
-          </a:xfrm>
-          <a:prstGeom prst="rect">
-            <a:avLst/>
-          </a:prstGeom>
-          <a:noFill/>
-        </p:spPr>
-        <p:txBody>
-          <a:bodyPr wrap="square" anchor="t">
-            <a:spAutoFit/>
-          </a:bodyPr>
-          <a:lstStyle/>
-          <a:p>
-            <a:pPr algn="l">
-              <a:spcAft>
-                <a:spcPts val="0"/>
-              </a:spcAft>
-            </a:pPr>
-            <a:r>
-              <a:rPr sz="2200" b="1" i="0">
-                <a:solidFill>
-                  <a:srgbClr val="0A1F2E"/>
-                </a:solidFill>
-                <a:latin typeface="Calibri"/>
-              </a:rPr>
-              <a:t>Intelligence rooted in African community care</a:t>
-            </a:r>
-          </a:p>
-        </p:txBody>
-      </p:sp>
       <p:pic>
         <p:nvPicPr>
-          <p:cNvPr id="6" name="Picture 5" descr="deep_tech_collage_opt.jpg"/>
+          <p:cNvPr id="2" name="Picture 1" descr="outreach_hands_raised_01_opt.jpg"/>
           <p:cNvPicPr>
             <a:picLocks noChangeAspect="1"/>
           </p:cNvPicPr>
@@ -6880,8 +5662,8 @@
         </p:blipFill>
         <p:spPr>
           <a:xfrm>
-            <a:off x="411480" y="2065630"/>
-            <a:ext cx="5120640" cy="3412540"/>
+            <a:off x="0" y="0"/>
+            <a:ext cx="12191695" cy="6858000"/>
           </a:xfrm>
           <a:prstGeom prst="rect">
             <a:avLst/>
@@ -6890,758 +5672,14 @@
       </p:pic>
       <p:sp>
         <p:nvSpPr>
-          <p:cNvPr id="7" name="Rectangle 6"/>
+          <p:cNvPr id="3" name="Rectangle 2"/>
           <p:cNvSpPr/>
           <p:nvPr/>
         </p:nvSpPr>
         <p:spPr>
           <a:xfrm>
-            <a:off x="5852160" y="1197864"/>
-            <a:ext cx="5852160" cy="766572"/>
-          </a:xfrm>
-          <a:prstGeom prst="rect">
-            <a:avLst/>
-          </a:prstGeom>
-          <a:solidFill>
-            <a:srgbClr val="FFFFFF"/>
-          </a:solidFill>
-          <a:ln w="9525">
-            <a:solidFill>
-              <a:srgbClr val="D0DCDC"/>
-            </a:solidFill>
-          </a:ln>
-          <a:effectLst/>
-        </p:spPr>
-        <p:style>
-          <a:lnRef idx="1">
-            <a:schemeClr val="accent1"/>
-          </a:lnRef>
-          <a:fillRef idx="3">
-            <a:schemeClr val="accent1"/>
-          </a:fillRef>
-          <a:effectRef idx="2">
-            <a:schemeClr val="accent1"/>
-          </a:effectRef>
-          <a:fontRef idx="minor">
-            <a:schemeClr val="lt1"/>
-          </a:fontRef>
-        </p:style>
-        <p:txBody>
-          <a:bodyPr rtlCol="0" anchor="ctr"/>
-          <a:lstStyle/>
-          <a:p>
-            <a:pPr algn="ctr"/>
-          </a:p>
-        </p:txBody>
-      </p:sp>
-      <p:sp>
-        <p:nvSpPr>
-          <p:cNvPr id="8" name="TextBox 7"/>
-          <p:cNvSpPr txBox="1"/>
-          <p:nvPr/>
-        </p:nvSpPr>
-        <p:spPr>
-          <a:xfrm>
-            <a:off x="6035040" y="1252728"/>
-            <a:ext cx="5486400" cy="274320"/>
-          </a:xfrm>
-          <a:prstGeom prst="rect">
-            <a:avLst/>
-          </a:prstGeom>
-          <a:noFill/>
-        </p:spPr>
-        <p:txBody>
-          <a:bodyPr wrap="square" anchor="t">
-            <a:spAutoFit/>
-          </a:bodyPr>
-          <a:lstStyle/>
-          <a:p>
-            <a:pPr algn="l">
-              <a:spcAft>
-                <a:spcPts val="0"/>
-              </a:spcAft>
-            </a:pPr>
-            <a:r>
-              <a:rPr sz="1400" b="1" i="0">
-                <a:solidFill>
-                  <a:srgbClr val="0D6E6E"/>
-                </a:solidFill>
-                <a:latin typeface="Calibri"/>
-              </a:rPr>
-              <a:t>Artificial Intelligence</a:t>
-            </a:r>
-          </a:p>
-        </p:txBody>
-      </p:sp>
-      <p:sp>
-        <p:nvSpPr>
-          <p:cNvPr id="9" name="TextBox 8"/>
-          <p:cNvSpPr txBox="1"/>
-          <p:nvPr/>
-        </p:nvSpPr>
-        <p:spPr>
-          <a:xfrm>
-            <a:off x="6035040" y="1527048"/>
-            <a:ext cx="5486400" cy="365760"/>
-          </a:xfrm>
-          <a:prstGeom prst="rect">
-            <a:avLst/>
-          </a:prstGeom>
-          <a:noFill/>
-        </p:spPr>
-        <p:txBody>
-          <a:bodyPr wrap="square" anchor="t">
-            <a:spAutoFit/>
-          </a:bodyPr>
-          <a:lstStyle/>
-          <a:p>
-            <a:pPr algn="l">
-              <a:spcAft>
-                <a:spcPts val="0"/>
-              </a:spcAft>
-            </a:pPr>
-            <a:r>
-              <a:rPr sz="1200" b="0" i="0">
-                <a:solidFill>
-                  <a:srgbClr val="3A4A54"/>
-                </a:solidFill>
-                <a:latin typeface="Calibri"/>
-              </a:rPr>
-              <a:t>Outbreak early warning; maternal and NCD risk scoring</a:t>
-            </a:r>
-          </a:p>
-        </p:txBody>
-      </p:sp>
-      <p:sp>
-        <p:nvSpPr>
-          <p:cNvPr id="10" name="Rectangle 9"/>
-          <p:cNvSpPr/>
-          <p:nvPr/>
-        </p:nvSpPr>
-        <p:spPr>
-          <a:xfrm>
-            <a:off x="5852160" y="2074164"/>
-            <a:ext cx="5852160" cy="766572"/>
-          </a:xfrm>
-          <a:prstGeom prst="rect">
-            <a:avLst/>
-          </a:prstGeom>
-          <a:solidFill>
-            <a:srgbClr val="FFFFFF"/>
-          </a:solidFill>
-          <a:ln w="9525">
-            <a:solidFill>
-              <a:srgbClr val="D0DCDC"/>
-            </a:solidFill>
-          </a:ln>
-          <a:effectLst/>
-        </p:spPr>
-        <p:style>
-          <a:lnRef idx="1">
-            <a:schemeClr val="accent1"/>
-          </a:lnRef>
-          <a:fillRef idx="3">
-            <a:schemeClr val="accent1"/>
-          </a:fillRef>
-          <a:effectRef idx="2">
-            <a:schemeClr val="accent1"/>
-          </a:effectRef>
-          <a:fontRef idx="minor">
-            <a:schemeClr val="lt1"/>
-          </a:fontRef>
-        </p:style>
-        <p:txBody>
-          <a:bodyPr rtlCol="0" anchor="ctr"/>
-          <a:lstStyle/>
-          <a:p>
-            <a:pPr algn="ctr"/>
-          </a:p>
-        </p:txBody>
-      </p:sp>
-      <p:sp>
-        <p:nvSpPr>
-          <p:cNvPr id="11" name="TextBox 10"/>
-          <p:cNvSpPr txBox="1"/>
-          <p:nvPr/>
-        </p:nvSpPr>
-        <p:spPr>
-          <a:xfrm>
-            <a:off x="6035040" y="2129028"/>
-            <a:ext cx="5486400" cy="274320"/>
-          </a:xfrm>
-          <a:prstGeom prst="rect">
-            <a:avLst/>
-          </a:prstGeom>
-          <a:noFill/>
-        </p:spPr>
-        <p:txBody>
-          <a:bodyPr wrap="square" anchor="t">
-            <a:spAutoFit/>
-          </a:bodyPr>
-          <a:lstStyle/>
-          <a:p>
-            <a:pPr algn="l">
-              <a:spcAft>
-                <a:spcPts val="0"/>
-              </a:spcAft>
-            </a:pPr>
-            <a:r>
-              <a:rPr sz="1400" b="1" i="0">
-                <a:solidFill>
-                  <a:srgbClr val="0D6E6E"/>
-                </a:solidFill>
-                <a:latin typeface="Calibri"/>
-              </a:rPr>
-              <a:t>Machine Learning</a:t>
-            </a:r>
-          </a:p>
-        </p:txBody>
-      </p:sp>
-      <p:sp>
-        <p:nvSpPr>
-          <p:cNvPr id="12" name="TextBox 11"/>
-          <p:cNvSpPr txBox="1"/>
-          <p:nvPr/>
-        </p:nvSpPr>
-        <p:spPr>
-          <a:xfrm>
-            <a:off x="6035040" y="2403348"/>
-            <a:ext cx="5486400" cy="365760"/>
-          </a:xfrm>
-          <a:prstGeom prst="rect">
-            <a:avLst/>
-          </a:prstGeom>
-          <a:noFill/>
-        </p:spPr>
-        <p:txBody>
-          <a:bodyPr wrap="square" anchor="t">
-            <a:spAutoFit/>
-          </a:bodyPr>
-          <a:lstStyle/>
-          <a:p>
-            <a:pPr algn="l">
-              <a:spcAft>
-                <a:spcPts val="0"/>
-              </a:spcAft>
-            </a:pPr>
-            <a:r>
-              <a:rPr sz="1200" b="0" i="0">
-                <a:solidFill>
-                  <a:srgbClr val="3A4A54"/>
-                </a:solidFill>
-                <a:latin typeface="Calibri"/>
-              </a:rPr>
-              <a:t>Learn from community patterns, seasons, and outreach outcomes</a:t>
-            </a:r>
-          </a:p>
-        </p:txBody>
-      </p:sp>
-      <p:sp>
-        <p:nvSpPr>
-          <p:cNvPr id="13" name="Rectangle 12"/>
-          <p:cNvSpPr/>
-          <p:nvPr/>
-        </p:nvSpPr>
-        <p:spPr>
-          <a:xfrm>
-            <a:off x="5852160" y="2950464"/>
-            <a:ext cx="5852160" cy="766572"/>
-          </a:xfrm>
-          <a:prstGeom prst="rect">
-            <a:avLst/>
-          </a:prstGeom>
-          <a:solidFill>
-            <a:srgbClr val="FFFFFF"/>
-          </a:solidFill>
-          <a:ln w="9525">
-            <a:solidFill>
-              <a:srgbClr val="D0DCDC"/>
-            </a:solidFill>
-          </a:ln>
-          <a:effectLst/>
-        </p:spPr>
-        <p:style>
-          <a:lnRef idx="1">
-            <a:schemeClr val="accent1"/>
-          </a:lnRef>
-          <a:fillRef idx="3">
-            <a:schemeClr val="accent1"/>
-          </a:fillRef>
-          <a:effectRef idx="2">
-            <a:schemeClr val="accent1"/>
-          </a:effectRef>
-          <a:fontRef idx="minor">
-            <a:schemeClr val="lt1"/>
-          </a:fontRef>
-        </p:style>
-        <p:txBody>
-          <a:bodyPr rtlCol="0" anchor="ctr"/>
-          <a:lstStyle/>
-          <a:p>
-            <a:pPr algn="ctr"/>
-          </a:p>
-        </p:txBody>
-      </p:sp>
-      <p:sp>
-        <p:nvSpPr>
-          <p:cNvPr id="14" name="TextBox 13"/>
-          <p:cNvSpPr txBox="1"/>
-          <p:nvPr/>
-        </p:nvSpPr>
-        <p:spPr>
-          <a:xfrm>
-            <a:off x="6035040" y="3005328"/>
-            <a:ext cx="5486400" cy="274320"/>
-          </a:xfrm>
-          <a:prstGeom prst="rect">
-            <a:avLst/>
-          </a:prstGeom>
-          <a:noFill/>
-        </p:spPr>
-        <p:txBody>
-          <a:bodyPr wrap="square" anchor="t">
-            <a:spAutoFit/>
-          </a:bodyPr>
-          <a:lstStyle/>
-          <a:p>
-            <a:pPr algn="l">
-              <a:spcAft>
-                <a:spcPts val="0"/>
-              </a:spcAft>
-            </a:pPr>
-            <a:r>
-              <a:rPr sz="1400" b="1" i="0">
-                <a:solidFill>
-                  <a:srgbClr val="0D6E6E"/>
-                </a:solidFill>
-                <a:latin typeface="Calibri"/>
-              </a:rPr>
-              <a:t>GIS Mapping</a:t>
-            </a:r>
-          </a:p>
-        </p:txBody>
-      </p:sp>
-      <p:sp>
-        <p:nvSpPr>
-          <p:cNvPr id="15" name="TextBox 14"/>
-          <p:cNvSpPr txBox="1"/>
-          <p:nvPr/>
-        </p:nvSpPr>
-        <p:spPr>
-          <a:xfrm>
-            <a:off x="6035040" y="3279648"/>
-            <a:ext cx="5486400" cy="365760"/>
-          </a:xfrm>
-          <a:prstGeom prst="rect">
-            <a:avLst/>
-          </a:prstGeom>
-          <a:noFill/>
-        </p:spPr>
-        <p:txBody>
-          <a:bodyPr wrap="square" anchor="t">
-            <a:spAutoFit/>
-          </a:bodyPr>
-          <a:lstStyle/>
-          <a:p>
-            <a:pPr algn="l">
-              <a:spcAft>
-                <a:spcPts val="0"/>
-              </a:spcAft>
-            </a:pPr>
-            <a:r>
-              <a:rPr sz="1200" b="0" i="0">
-                <a:solidFill>
-                  <a:srgbClr val="3A4A54"/>
-                </a:solidFill>
-                <a:latin typeface="Calibri"/>
-              </a:rPr>
-              <a:t>Disease distribution, hotspots, and resource gaps</a:t>
-            </a:r>
-          </a:p>
-        </p:txBody>
-      </p:sp>
-      <p:sp>
-        <p:nvSpPr>
-          <p:cNvPr id="16" name="Rectangle 15"/>
-          <p:cNvSpPr/>
-          <p:nvPr/>
-        </p:nvSpPr>
-        <p:spPr>
-          <a:xfrm>
-            <a:off x="5852160" y="3826764"/>
-            <a:ext cx="5852160" cy="766572"/>
-          </a:xfrm>
-          <a:prstGeom prst="rect">
-            <a:avLst/>
-          </a:prstGeom>
-          <a:solidFill>
-            <a:srgbClr val="FFFFFF"/>
-          </a:solidFill>
-          <a:ln w="9525">
-            <a:solidFill>
-              <a:srgbClr val="D0DCDC"/>
-            </a:solidFill>
-          </a:ln>
-          <a:effectLst/>
-        </p:spPr>
-        <p:style>
-          <a:lnRef idx="1">
-            <a:schemeClr val="accent1"/>
-          </a:lnRef>
-          <a:fillRef idx="3">
-            <a:schemeClr val="accent1"/>
-          </a:fillRef>
-          <a:effectRef idx="2">
-            <a:schemeClr val="accent1"/>
-          </a:effectRef>
-          <a:fontRef idx="minor">
-            <a:schemeClr val="lt1"/>
-          </a:fontRef>
-        </p:style>
-        <p:txBody>
-          <a:bodyPr rtlCol="0" anchor="ctr"/>
-          <a:lstStyle/>
-          <a:p>
-            <a:pPr algn="ctr"/>
-          </a:p>
-        </p:txBody>
-      </p:sp>
-      <p:sp>
-        <p:nvSpPr>
-          <p:cNvPr id="17" name="TextBox 16"/>
-          <p:cNvSpPr txBox="1"/>
-          <p:nvPr/>
-        </p:nvSpPr>
-        <p:spPr>
-          <a:xfrm>
-            <a:off x="6035040" y="3881628"/>
-            <a:ext cx="5486400" cy="274320"/>
-          </a:xfrm>
-          <a:prstGeom prst="rect">
-            <a:avLst/>
-          </a:prstGeom>
-          <a:noFill/>
-        </p:spPr>
-        <p:txBody>
-          <a:bodyPr wrap="square" anchor="t">
-            <a:spAutoFit/>
-          </a:bodyPr>
-          <a:lstStyle/>
-          <a:p>
-            <a:pPr algn="l">
-              <a:spcAft>
-                <a:spcPts val="0"/>
-              </a:spcAft>
-            </a:pPr>
-            <a:r>
-              <a:rPr sz="1400" b="1" i="0">
-                <a:solidFill>
-                  <a:srgbClr val="0D6E6E"/>
-                </a:solidFill>
-                <a:latin typeface="Calibri"/>
-              </a:rPr>
-              <a:t>Mobile Data Collection</a:t>
-            </a:r>
-          </a:p>
-        </p:txBody>
-      </p:sp>
-      <p:sp>
-        <p:nvSpPr>
-          <p:cNvPr id="18" name="TextBox 17"/>
-          <p:cNvSpPr txBox="1"/>
-          <p:nvPr/>
-        </p:nvSpPr>
-        <p:spPr>
-          <a:xfrm>
-            <a:off x="6035040" y="4155948"/>
-            <a:ext cx="5486400" cy="365760"/>
-          </a:xfrm>
-          <a:prstGeom prst="rect">
-            <a:avLst/>
-          </a:prstGeom>
-          <a:noFill/>
-        </p:spPr>
-        <p:txBody>
-          <a:bodyPr wrap="square" anchor="t">
-            <a:spAutoFit/>
-          </a:bodyPr>
-          <a:lstStyle/>
-          <a:p>
-            <a:pPr algn="l">
-              <a:spcAft>
-                <a:spcPts val="0"/>
-              </a:spcAft>
-            </a:pPr>
-            <a:r>
-              <a:rPr sz="1200" b="0" i="0">
-                <a:solidFill>
-                  <a:srgbClr val="3A4A54"/>
-                </a:solidFill>
-                <a:latin typeface="Calibri"/>
-              </a:rPr>
-              <a:t>Offline-capable CHW/VHT capture at household level</a:t>
-            </a:r>
-          </a:p>
-        </p:txBody>
-      </p:sp>
-      <p:sp>
-        <p:nvSpPr>
-          <p:cNvPr id="19" name="Rectangle 18"/>
-          <p:cNvSpPr/>
-          <p:nvPr/>
-        </p:nvSpPr>
-        <p:spPr>
-          <a:xfrm>
-            <a:off x="5852160" y="4703064"/>
-            <a:ext cx="5852160" cy="766572"/>
-          </a:xfrm>
-          <a:prstGeom prst="rect">
-            <a:avLst/>
-          </a:prstGeom>
-          <a:solidFill>
-            <a:srgbClr val="FFFFFF"/>
-          </a:solidFill>
-          <a:ln w="9525">
-            <a:solidFill>
-              <a:srgbClr val="D0DCDC"/>
-            </a:solidFill>
-          </a:ln>
-          <a:effectLst/>
-        </p:spPr>
-        <p:style>
-          <a:lnRef idx="1">
-            <a:schemeClr val="accent1"/>
-          </a:lnRef>
-          <a:fillRef idx="3">
-            <a:schemeClr val="accent1"/>
-          </a:fillRef>
-          <a:effectRef idx="2">
-            <a:schemeClr val="accent1"/>
-          </a:effectRef>
-          <a:fontRef idx="minor">
-            <a:schemeClr val="lt1"/>
-          </a:fontRef>
-        </p:style>
-        <p:txBody>
-          <a:bodyPr rtlCol="0" anchor="ctr"/>
-          <a:lstStyle/>
-          <a:p>
-            <a:pPr algn="ctr"/>
-          </a:p>
-        </p:txBody>
-      </p:sp>
-      <p:sp>
-        <p:nvSpPr>
-          <p:cNvPr id="20" name="TextBox 19"/>
-          <p:cNvSpPr txBox="1"/>
-          <p:nvPr/>
-        </p:nvSpPr>
-        <p:spPr>
-          <a:xfrm>
-            <a:off x="6035040" y="4757928"/>
-            <a:ext cx="5486400" cy="274320"/>
-          </a:xfrm>
-          <a:prstGeom prst="rect">
-            <a:avLst/>
-          </a:prstGeom>
-          <a:noFill/>
-        </p:spPr>
-        <p:txBody>
-          <a:bodyPr wrap="square" anchor="t">
-            <a:spAutoFit/>
-          </a:bodyPr>
-          <a:lstStyle/>
-          <a:p>
-            <a:pPr algn="l">
-              <a:spcAft>
-                <a:spcPts val="0"/>
-              </a:spcAft>
-            </a:pPr>
-            <a:r>
-              <a:rPr sz="1400" b="1" i="0">
-                <a:solidFill>
-                  <a:srgbClr val="0D6E6E"/>
-                </a:solidFill>
-                <a:latin typeface="Calibri"/>
-              </a:rPr>
-              <a:t>Cloud Computing</a:t>
-            </a:r>
-          </a:p>
-        </p:txBody>
-      </p:sp>
-      <p:sp>
-        <p:nvSpPr>
-          <p:cNvPr id="21" name="TextBox 20"/>
-          <p:cNvSpPr txBox="1"/>
-          <p:nvPr/>
-        </p:nvSpPr>
-        <p:spPr>
-          <a:xfrm>
-            <a:off x="6035040" y="5032248"/>
-            <a:ext cx="5486400" cy="365760"/>
-          </a:xfrm>
-          <a:prstGeom prst="rect">
-            <a:avLst/>
-          </a:prstGeom>
-          <a:noFill/>
-        </p:spPr>
-        <p:txBody>
-          <a:bodyPr wrap="square" anchor="t">
-            <a:spAutoFit/>
-          </a:bodyPr>
-          <a:lstStyle/>
-          <a:p>
-            <a:pPr algn="l">
-              <a:spcAft>
-                <a:spcPts val="0"/>
-              </a:spcAft>
-            </a:pPr>
-            <a:r>
-              <a:rPr sz="1200" b="0" i="0">
-                <a:solidFill>
-                  <a:srgbClr val="3A4A54"/>
-                </a:solidFill>
-                <a:latin typeface="Calibri"/>
-              </a:rPr>
-              <a:t>Secure sync across facilities and partners</a:t>
-            </a:r>
-          </a:p>
-        </p:txBody>
-      </p:sp>
-      <p:sp>
-        <p:nvSpPr>
-          <p:cNvPr id="22" name="Rectangle 21"/>
-          <p:cNvSpPr/>
-          <p:nvPr/>
-        </p:nvSpPr>
-        <p:spPr>
-          <a:xfrm>
-            <a:off x="5852160" y="5579364"/>
-            <a:ext cx="5852160" cy="766572"/>
-          </a:xfrm>
-          <a:prstGeom prst="rect">
-            <a:avLst/>
-          </a:prstGeom>
-          <a:solidFill>
-            <a:srgbClr val="FFFFFF"/>
-          </a:solidFill>
-          <a:ln w="9525">
-            <a:solidFill>
-              <a:srgbClr val="D0DCDC"/>
-            </a:solidFill>
-          </a:ln>
-          <a:effectLst/>
-        </p:spPr>
-        <p:style>
-          <a:lnRef idx="1">
-            <a:schemeClr val="accent1"/>
-          </a:lnRef>
-          <a:fillRef idx="3">
-            <a:schemeClr val="accent1"/>
-          </a:fillRef>
-          <a:effectRef idx="2">
-            <a:schemeClr val="accent1"/>
-          </a:effectRef>
-          <a:fontRef idx="minor">
-            <a:schemeClr val="lt1"/>
-          </a:fontRef>
-        </p:style>
-        <p:txBody>
-          <a:bodyPr rtlCol="0" anchor="ctr"/>
-          <a:lstStyle/>
-          <a:p>
-            <a:pPr algn="ctr"/>
-          </a:p>
-        </p:txBody>
-      </p:sp>
-      <p:sp>
-        <p:nvSpPr>
-          <p:cNvPr id="23" name="TextBox 22"/>
-          <p:cNvSpPr txBox="1"/>
-          <p:nvPr/>
-        </p:nvSpPr>
-        <p:spPr>
-          <a:xfrm>
-            <a:off x="6035040" y="5634228"/>
-            <a:ext cx="5486400" cy="274320"/>
-          </a:xfrm>
-          <a:prstGeom prst="rect">
-            <a:avLst/>
-          </a:prstGeom>
-          <a:noFill/>
-        </p:spPr>
-        <p:txBody>
-          <a:bodyPr wrap="square" anchor="t">
-            <a:spAutoFit/>
-          </a:bodyPr>
-          <a:lstStyle/>
-          <a:p>
-            <a:pPr algn="l">
-              <a:spcAft>
-                <a:spcPts val="0"/>
-              </a:spcAft>
-            </a:pPr>
-            <a:r>
-              <a:rPr sz="1400" b="1" i="0">
-                <a:solidFill>
-                  <a:srgbClr val="0D6E6E"/>
-                </a:solidFill>
-                <a:latin typeface="Calibri"/>
-              </a:rPr>
-              <a:t>Analytics Dashboards</a:t>
-            </a:r>
-          </a:p>
-        </p:txBody>
-      </p:sp>
-      <p:sp>
-        <p:nvSpPr>
-          <p:cNvPr id="24" name="TextBox 23"/>
-          <p:cNvSpPr txBox="1"/>
-          <p:nvPr/>
-        </p:nvSpPr>
-        <p:spPr>
-          <a:xfrm>
-            <a:off x="6035040" y="5908548"/>
-            <a:ext cx="5486400" cy="365760"/>
-          </a:xfrm>
-          <a:prstGeom prst="rect">
-            <a:avLst/>
-          </a:prstGeom>
-          <a:noFill/>
-        </p:spPr>
-        <p:txBody>
-          <a:bodyPr wrap="square" anchor="t">
-            <a:spAutoFit/>
-          </a:bodyPr>
-          <a:lstStyle/>
-          <a:p>
-            <a:pPr algn="l">
-              <a:spcAft>
-                <a:spcPts val="0"/>
-              </a:spcAft>
-            </a:pPr>
-            <a:r>
-              <a:rPr sz="1200" b="0" i="0">
-                <a:solidFill>
-                  <a:srgbClr val="3A4A54"/>
-                </a:solidFill>
-                <a:latin typeface="Calibri"/>
-              </a:rPr>
-              <a:t>Real-time views for clinics, districts, and NGOs</a:t>
-            </a:r>
-          </a:p>
-        </p:txBody>
-      </p:sp>
-      <p:sp>
-        <p:nvSpPr>
-          <p:cNvPr id="25" name="Rectangle 24"/>
-          <p:cNvSpPr/>
-          <p:nvPr/>
-        </p:nvSpPr>
-        <p:spPr>
-          <a:xfrm>
-            <a:off x="0" y="6565392"/>
-            <a:ext cx="12191695" cy="292608"/>
+            <a:off x="0" y="4480560"/>
+            <a:ext cx="12191695" cy="2377440"/>
           </a:xfrm>
           <a:prstGeom prst="rect">
             <a:avLst/>
@@ -7652,7 +5690,6 @@
           <a:ln>
             <a:noFill/>
           </a:ln>
-          <a:effectLst/>
         </p:spPr>
         <p:style>
           <a:lnRef idx="1">
@@ -7678,14 +5715,14 @@
       </p:sp>
       <p:sp>
         <p:nvSpPr>
-          <p:cNvPr id="26" name="TextBox 25"/>
+          <p:cNvPr id="4" name="TextBox 3"/>
           <p:cNvSpPr txBox="1"/>
           <p:nvPr/>
         </p:nvSpPr>
         <p:spPr>
           <a:xfrm>
-            <a:off x="365760" y="6574536"/>
-            <a:ext cx="9144000" cy="274320"/>
+            <a:off x="548640" y="4846320"/>
+            <a:ext cx="10972800" cy="502920"/>
           </a:xfrm>
           <a:prstGeom prst="rect">
             <a:avLst/>
@@ -7693,38 +5730,34 @@
           <a:noFill/>
         </p:spPr>
         <p:txBody>
-          <a:bodyPr wrap="square" anchor="ctr">
+          <a:bodyPr wrap="square">
             <a:spAutoFit/>
           </a:bodyPr>
           <a:lstStyle/>
           <a:p>
-            <a:pPr algn="l">
-              <a:spcAft>
-                <a:spcPts val="0"/>
-              </a:spcAft>
-            </a:pPr>
-            <a:r>
-              <a:rPr sz="900" b="0" i="0">
+            <a:pPr algn="l"/>
+            <a:r>
+              <a:rPr sz="2200" b="1" i="0">
                 <a:solidFill>
                   <a:srgbClr val="FFFFFF"/>
                 </a:solidFill>
                 <a:latin typeface="Calibri"/>
               </a:rPr>
-              <a:t>FairBanks FCHIP  |  AUDA-NEPAD Youth SRH Ambassadors Initiat  |  Your health, our mission.</a:t>
-            </a:r>
-          </a:p>
-        </p:txBody>
-      </p:sp>
-      <p:sp>
-        <p:nvSpPr>
-          <p:cNvPr id="27" name="TextBox 26"/>
+              <a:t>Youth SRH advocacy rooted in community — ready to serve continentally.</a:t>
+            </a:r>
+          </a:p>
+        </p:txBody>
+      </p:sp>
+      <p:sp>
+        <p:nvSpPr>
+          <p:cNvPr id="5" name="TextBox 4"/>
           <p:cNvSpPr txBox="1"/>
           <p:nvPr/>
         </p:nvSpPr>
         <p:spPr>
           <a:xfrm>
-            <a:off x="11094415" y="6574536"/>
-            <a:ext cx="731520" cy="274320"/>
+            <a:off x="548640" y="5715000"/>
+            <a:ext cx="10972800" cy="320040"/>
           </a:xfrm>
           <a:prstGeom prst="rect">
             <a:avLst/>
@@ -7732,144 +5765,34 @@
           <a:noFill/>
         </p:spPr>
         <p:txBody>
-          <a:bodyPr wrap="square" anchor="ctr">
+          <a:bodyPr wrap="square">
             <a:spAutoFit/>
           </a:bodyPr>
           <a:lstStyle/>
           <a:p>
-            <a:pPr algn="r">
-              <a:spcAft>
-                <a:spcPts val="0"/>
-              </a:spcAft>
-            </a:pPr>
-            <a:r>
-              <a:rPr sz="900" b="0" i="0">
+            <a:pPr algn="l"/>
+            <a:r>
+              <a:rPr sz="1400" b="1" i="0">
                 <a:solidFill>
                   <a:srgbClr val="FFFFFF"/>
                 </a:solidFill>
                 <a:latin typeface="Calibri"/>
               </a:rPr>
-              <a:t>8</a:t>
-            </a:r>
-          </a:p>
-        </p:txBody>
-      </p:sp>
-    </p:spTree>
-  </p:cSld>
-  <p:clrMapOvr>
-    <a:masterClrMapping/>
-  </p:clrMapOvr>
-</p:sld>
-</file>
-
-<file path=ppt/slides/slide9.xml><?xml version="1.0" encoding="utf-8"?>
-<p:sld xmlns:a="http://schemas.openxmlformats.org/drawingml/2006/main" xmlns:p="http://schemas.openxmlformats.org/presentationml/2006/main" xmlns:r="http://schemas.openxmlformats.org/officeDocument/2006/relationships">
-  <p:cSld>
-    <p:spTree>
-      <p:nvGrpSpPr>
-        <p:cNvPr id="1" name=""/>
-        <p:cNvGrpSpPr/>
-        <p:nvPr/>
-      </p:nvGrpSpPr>
-      <p:grpSpPr/>
-      <p:sp>
-        <p:nvSpPr>
-          <p:cNvPr id="2" name="Rectangle 1"/>
-          <p:cNvSpPr/>
-          <p:nvPr/>
-        </p:nvSpPr>
-        <p:spPr>
-          <a:xfrm>
-            <a:off x="0" y="0"/>
-            <a:ext cx="12191695" cy="960120"/>
-          </a:xfrm>
-          <a:prstGeom prst="rect">
-            <a:avLst/>
-          </a:prstGeom>
-          <a:solidFill>
-            <a:srgbClr val="F7F5F0"/>
-          </a:solidFill>
-          <a:ln>
-            <a:noFill/>
-          </a:ln>
-          <a:effectLst/>
-        </p:spPr>
-        <p:style>
-          <a:lnRef idx="1">
-            <a:schemeClr val="accent1"/>
-          </a:lnRef>
-          <a:fillRef idx="3">
-            <a:schemeClr val="accent1"/>
-          </a:fillRef>
-          <a:effectRef idx="2">
-            <a:schemeClr val="accent1"/>
-          </a:effectRef>
-          <a:fontRef idx="minor">
-            <a:schemeClr val="lt1"/>
-          </a:fontRef>
-        </p:style>
-        <p:txBody>
-          <a:bodyPr rtlCol="0" anchor="ctr"/>
-          <a:lstStyle/>
-          <a:p>
-            <a:pPr algn="ctr"/>
-          </a:p>
-        </p:txBody>
-      </p:sp>
-      <p:sp>
-        <p:nvSpPr>
-          <p:cNvPr id="3" name="Rectangle 2"/>
-          <p:cNvSpPr/>
-          <p:nvPr/>
-        </p:nvSpPr>
-        <p:spPr>
-          <a:xfrm>
-            <a:off x="0" y="0"/>
-            <a:ext cx="164592" cy="960120"/>
-          </a:xfrm>
-          <a:prstGeom prst="rect">
-            <a:avLst/>
-          </a:prstGeom>
-          <a:solidFill>
-            <a:srgbClr val="0D6E6E"/>
-          </a:solidFill>
-          <a:ln>
-            <a:noFill/>
-          </a:ln>
-          <a:effectLst/>
-        </p:spPr>
-        <p:style>
-          <a:lnRef idx="1">
-            <a:schemeClr val="accent1"/>
-          </a:lnRef>
-          <a:fillRef idx="3">
-            <a:schemeClr val="accent1"/>
-          </a:fillRef>
-          <a:effectRef idx="2">
-            <a:schemeClr val="accent1"/>
-          </a:effectRef>
-          <a:fontRef idx="minor">
-            <a:schemeClr val="lt1"/>
-          </a:fontRef>
-        </p:style>
-        <p:txBody>
-          <a:bodyPr rtlCol="0" anchor="ctr"/>
-          <a:lstStyle/>
-          <a:p>
-            <a:pPr algn="ctr"/>
-          </a:p>
-        </p:txBody>
-      </p:sp>
-      <p:sp>
-        <p:nvSpPr>
-          <p:cNvPr id="4" name="TextBox 3"/>
+              <a:t>Your health, our mission.</a:t>
+            </a:r>
+          </a:p>
+        </p:txBody>
+      </p:sp>
+      <p:sp>
+        <p:nvSpPr>
+          <p:cNvPr id="6" name="TextBox 5"/>
           <p:cNvSpPr txBox="1"/>
           <p:nvPr/>
         </p:nvSpPr>
         <p:spPr>
           <a:xfrm>
-            <a:off x="457200" y="109728"/>
-            <a:ext cx="10972800" cy="256032"/>
+            <a:off x="548640" y="6172200"/>
+            <a:ext cx="10972800" cy="274320"/>
           </a:xfrm>
           <a:prstGeom prst="rect">
             <a:avLst/>
@@ -7877,328 +5800,20 @@
           <a:noFill/>
         </p:spPr>
         <p:txBody>
-          <a:bodyPr wrap="square" anchor="t">
+          <a:bodyPr wrap="square">
             <a:spAutoFit/>
           </a:bodyPr>
           <a:lstStyle/>
           <a:p>
-            <a:pPr algn="l">
-              <a:spcAft>
-                <a:spcPts val="0"/>
-              </a:spcAft>
-            </a:pPr>
-            <a:r>
-              <a:rPr sz="1100" b="1" i="0">
+            <a:pPr algn="l"/>
+            <a:r>
+              <a:rPr sz="1200" b="0" i="0">
                 <a:solidFill>
-                  <a:srgbClr val="C45C26"/>
+                  <a:srgbClr val="F2C79B"/>
                 </a:solidFill>
                 <a:latin typeface="Calibri"/>
               </a:rPr>
-              <a:t>OUR MODEL</a:t>
-            </a:r>
-          </a:p>
-        </p:txBody>
-      </p:sp>
-      <p:sp>
-        <p:nvSpPr>
-          <p:cNvPr id="5" name="TextBox 4"/>
-          <p:cNvSpPr txBox="1"/>
-          <p:nvPr/>
-        </p:nvSpPr>
-        <p:spPr>
-          <a:xfrm>
-            <a:off x="457200" y="384048"/>
-            <a:ext cx="11247120" cy="475488"/>
-          </a:xfrm>
-          <a:prstGeom prst="rect">
-            <a:avLst/>
-          </a:prstGeom>
-          <a:noFill/>
-        </p:spPr>
-        <p:txBody>
-          <a:bodyPr wrap="square" anchor="t">
-            <a:spAutoFit/>
-          </a:bodyPr>
-          <a:lstStyle/>
-          <a:p>
-            <a:pPr algn="l">
-              <a:spcAft>
-                <a:spcPts val="0"/>
-              </a:spcAft>
-            </a:pPr>
-            <a:r>
-              <a:rPr sz="2200" b="1" i="0">
-                <a:solidFill>
-                  <a:srgbClr val="0A1F2E"/>
-                </a:solidFill>
-                <a:latin typeface="Calibri"/>
-              </a:rPr>
-              <a:t>Communities first — intelligence that serves care</a:t>
-            </a:r>
-          </a:p>
-        </p:txBody>
-      </p:sp>
-      <p:sp>
-        <p:nvSpPr>
-          <p:cNvPr id="6" name="TextBox 5"/>
-          <p:cNvSpPr txBox="1"/>
-          <p:nvPr/>
-        </p:nvSpPr>
-        <p:spPr>
-          <a:xfrm>
-            <a:off x="502920" y="1234440"/>
-            <a:ext cx="5760720" cy="5074920"/>
-          </a:xfrm>
-          <a:prstGeom prst="rect">
-            <a:avLst/>
-          </a:prstGeom>
-          <a:noFill/>
-        </p:spPr>
-        <p:txBody>
-          <a:bodyPr wrap="square">
-            <a:spAutoFit/>
-          </a:bodyPr>
-          <a:lstStyle/>
-          <a:p>
-            <a:pPr>
-              <a:spcAft>
-                <a:spcPts val="800"/>
-              </a:spcAft>
-            </a:pPr>
-            <a:r>
-              <a:rPr sz="1400">
-                <a:solidFill>
-                  <a:srgbClr val="1E2F38"/>
-                </a:solidFill>
-                <a:latin typeface="Calibri"/>
-              </a:rPr>
-              <a:t>•  Community members identify needs and own solutions</a:t>
-            </a:r>
-          </a:p>
-          <a:p>
-            <a:pPr>
-              <a:spcAft>
-                <a:spcPts val="800"/>
-              </a:spcAft>
-            </a:pPr>
-            <a:r>
-              <a:rPr sz="1400">
-                <a:solidFill>
-                  <a:srgbClr val="1E2F38"/>
-                </a:solidFill>
-                <a:latin typeface="Calibri"/>
-              </a:rPr>
-              <a:t>•  CHWs / VHTs bridge homes to clinics</a:t>
-            </a:r>
-          </a:p>
-          <a:p>
-            <a:pPr>
-              <a:spcAft>
-                <a:spcPts val="800"/>
-              </a:spcAft>
-            </a:pPr>
-            <a:r>
-              <a:rPr sz="1400">
-                <a:solidFill>
-                  <a:srgbClr val="1E2F38"/>
-                </a:solidFill>
-                <a:latin typeface="Calibri"/>
-              </a:rPr>
-              <a:t>•  FairBanks Community Reach programmes deliver outreach</a:t>
-            </a:r>
-          </a:p>
-          <a:p>
-            <a:pPr>
-              <a:spcAft>
-                <a:spcPts val="800"/>
-              </a:spcAft>
-            </a:pPr>
-            <a:r>
-              <a:rPr sz="1400">
-                <a:solidFill>
-                  <a:srgbClr val="1E2F38"/>
-                </a:solidFill>
-                <a:latin typeface="Calibri"/>
-              </a:rPr>
-              <a:t>•  FairBanks Medical Centre provides clinical care</a:t>
-            </a:r>
-          </a:p>
-          <a:p>
-            <a:pPr>
-              <a:spcAft>
-                <a:spcPts val="800"/>
-              </a:spcAft>
-            </a:pPr>
-            <a:r>
-              <a:rPr sz="1400">
-                <a:solidFill>
-                  <a:srgbClr val="1E2F38"/>
-                </a:solidFill>
-                <a:latin typeface="Calibri"/>
-              </a:rPr>
-              <a:t>•  Research, partnerships, and skills strengthen the system</a:t>
-            </a:r>
-          </a:p>
-          <a:p>
-            <a:pPr>
-              <a:spcAft>
-                <a:spcPts val="800"/>
-              </a:spcAft>
-            </a:pPr>
-            <a:r>
-              <a:rPr sz="1400">
-                <a:solidFill>
-                  <a:srgbClr val="1E2F38"/>
-                </a:solidFill>
-                <a:latin typeface="Calibri"/>
-              </a:rPr>
-              <a:t>•  Livelihoods and empowerment make health gains last</a:t>
-            </a:r>
-          </a:p>
-        </p:txBody>
-      </p:sp>
-      <p:pic>
-        <p:nvPicPr>
-          <p:cNvPr id="7" name="Picture 6" descr="gis_hotspots_opt.jpg"/>
-          <p:cNvPicPr>
-            <a:picLocks noChangeAspect="1"/>
-          </p:cNvPicPr>
-          <p:nvPr/>
-        </p:nvPicPr>
-        <p:blipFill>
-          <a:blip r:embed="rId2"/>
-          <a:stretch>
-            <a:fillRect/>
-          </a:stretch>
-        </p:blipFill>
-        <p:spPr>
-          <a:xfrm>
-            <a:off x="6492240" y="2035160"/>
-            <a:ext cx="5212080" cy="3473479"/>
-          </a:xfrm>
-          <a:prstGeom prst="rect">
-            <a:avLst/>
-          </a:prstGeom>
-        </p:spPr>
-      </p:pic>
-      <p:sp>
-        <p:nvSpPr>
-          <p:cNvPr id="8" name="Rectangle 7"/>
-          <p:cNvSpPr/>
-          <p:nvPr/>
-        </p:nvSpPr>
-        <p:spPr>
-          <a:xfrm>
-            <a:off x="0" y="6565392"/>
-            <a:ext cx="12191695" cy="292608"/>
-          </a:xfrm>
-          <a:prstGeom prst="rect">
-            <a:avLst/>
-          </a:prstGeom>
-          <a:solidFill>
-            <a:srgbClr val="0A1F2E"/>
-          </a:solidFill>
-          <a:ln>
-            <a:noFill/>
-          </a:ln>
-          <a:effectLst/>
-        </p:spPr>
-        <p:style>
-          <a:lnRef idx="1">
-            <a:schemeClr val="accent1"/>
-          </a:lnRef>
-          <a:fillRef idx="3">
-            <a:schemeClr val="accent1"/>
-          </a:fillRef>
-          <a:effectRef idx="2">
-            <a:schemeClr val="accent1"/>
-          </a:effectRef>
-          <a:fontRef idx="minor">
-            <a:schemeClr val="lt1"/>
-          </a:fontRef>
-        </p:style>
-        <p:txBody>
-          <a:bodyPr rtlCol="0" anchor="ctr"/>
-          <a:lstStyle/>
-          <a:p>
-            <a:pPr algn="ctr"/>
-          </a:p>
-        </p:txBody>
-      </p:sp>
-      <p:sp>
-        <p:nvSpPr>
-          <p:cNvPr id="9" name="TextBox 8"/>
-          <p:cNvSpPr txBox="1"/>
-          <p:nvPr/>
-        </p:nvSpPr>
-        <p:spPr>
-          <a:xfrm>
-            <a:off x="365760" y="6574536"/>
-            <a:ext cx="9144000" cy="274320"/>
-          </a:xfrm>
-          <a:prstGeom prst="rect">
-            <a:avLst/>
-          </a:prstGeom>
-          <a:noFill/>
-        </p:spPr>
-        <p:txBody>
-          <a:bodyPr wrap="square" anchor="ctr">
-            <a:spAutoFit/>
-          </a:bodyPr>
-          <a:lstStyle/>
-          <a:p>
-            <a:pPr algn="l">
-              <a:spcAft>
-                <a:spcPts val="0"/>
-              </a:spcAft>
-            </a:pPr>
-            <a:r>
-              <a:rPr sz="900" b="0" i="0">
-                <a:solidFill>
-                  <a:srgbClr val="FFFFFF"/>
-                </a:solidFill>
-                <a:latin typeface="Calibri"/>
-              </a:rPr>
-              <a:t>FairBanks FCHIP  |  AUDA-NEPAD Youth SRH Ambassadors Initiat  |  Your health, our mission.</a:t>
-            </a:r>
-          </a:p>
-        </p:txBody>
-      </p:sp>
-      <p:sp>
-        <p:nvSpPr>
-          <p:cNvPr id="10" name="TextBox 9"/>
-          <p:cNvSpPr txBox="1"/>
-          <p:nvPr/>
-        </p:nvSpPr>
-        <p:spPr>
-          <a:xfrm>
-            <a:off x="11094415" y="6574536"/>
-            <a:ext cx="731520" cy="274320"/>
-          </a:xfrm>
-          <a:prstGeom prst="rect">
-            <a:avLst/>
-          </a:prstGeom>
-          <a:noFill/>
-        </p:spPr>
-        <p:txBody>
-          <a:bodyPr wrap="square" anchor="ctr">
-            <a:spAutoFit/>
-          </a:bodyPr>
-          <a:lstStyle/>
-          <a:p>
-            <a:pPr algn="r">
-              <a:spcAft>
-                <a:spcPts val="0"/>
-              </a:spcAft>
-            </a:pPr>
-            <a:r>
-              <a:rPr sz="900" b="0" i="0">
-                <a:solidFill>
-                  <a:srgbClr val="FFFFFF"/>
-                </a:solidFill>
-                <a:latin typeface="Calibri"/>
-              </a:rPr>
-              <a:t>9</a:t>
+              <a:t>Application deadline: 17 July 2026</a:t>
             </a:r>
           </a:p>
         </p:txBody>

</xml_diff>